<commit_message>
Polish the slide-effects example deck
Redesign the example into a presentation-ready 4-slide deck (title, agenda,
hero metric, closing) with a cohesive palette, gradient backgrounds, and
gradient-filled headlines. The agenda uses numbered group rows instead of tight
text-background highlights so it stays cleanly aligned in PowerPoint, and the
hero metric carries a list of animations (box in, hold, fade out).

Co-Authored-By: Claude Opus 4.8 <noreply@anthropic.com>
Claude-Session: https://claude.ai/code/session_01TpdN8ZGDXbofsc2mQRueCa
</commit_message>
<xml_diff>
--- a/examples/slide_effects_deck.pptx
+++ b/examples/slide_effects_deck.pptx
@@ -3105,8 +3105,62 @@
           <a:prstGeom prst="rect">
             <a:avLst/>
           </a:prstGeom>
+          <a:gradFill rotWithShape="1">
+            <a:gsLst>
+              <a:gs pos="0">
+                <a:srgbClr val="0A1626"/>
+              </a:gs>
+              <a:gs pos="100000">
+                <a:srgbClr val="122849"/>
+              </a:gs>
+            </a:gsLst>
+            <a:lin ang="8100000" scaled="0"/>
+          </a:gradFill>
+          <a:ln>
+            <a:noFill/>
+          </a:ln>
+          <a:effectLst/>
+        </p:spPr>
+        <p:style>
+          <a:lnRef idx="1">
+            <a:schemeClr val="accent1"/>
+          </a:lnRef>
+          <a:fillRef idx="3">
+            <a:schemeClr val="accent1"/>
+          </a:fillRef>
+          <a:effectRef idx="2">
+            <a:schemeClr val="accent1"/>
+          </a:effectRef>
+          <a:fontRef idx="minor">
+            <a:schemeClr val="lt1"/>
+          </a:fontRef>
+        </p:style>
+        <p:txBody>
+          <a:bodyPr rtlCol="0" anchor="ctr"/>
+          <a:lstStyle/>
+          <a:p>
+            <a:pPr algn="ctr"/>
+          </a:p>
+        </p:txBody>
+      </p:sp>
+      <p:sp>
+        <p:nvSpPr>
+          <p:cNvPr id="3" name="Oval 2"/>
+          <p:cNvSpPr/>
+          <p:nvPr/>
+        </p:nvSpPr>
+        <p:spPr>
+          <a:xfrm>
+            <a:off x="8248650" y="-1657350"/>
+            <a:ext cx="4953000" cy="4953000"/>
+          </a:xfrm>
+          <a:prstGeom prst="ellipse">
+            <a:avLst/>
+          </a:prstGeom>
           <a:solidFill>
-            <a:srgbClr val="0B1B2B"/>
+            <a:srgbClr val="163358">
+              <a:alpha val="34901"/>
+            </a:srgbClr>
           </a:solidFill>
           <a:ln>
             <a:noFill/>
@@ -3137,56 +3191,14 @@
       </p:sp>
       <p:sp>
         <p:nvSpPr>
-          <p:cNvPr id="3" name="TextBox 2"/>
-          <p:cNvSpPr txBox="1"/>
-          <p:nvPr/>
-        </p:nvSpPr>
-        <p:spPr>
-          <a:xfrm>
-            <a:off x="1295400" y="2486025"/>
-            <a:ext cx="9591675" cy="876300"/>
-          </a:xfrm>
-          <a:prstGeom prst="rect">
-            <a:avLst/>
-          </a:prstGeom>
-          <a:noFill/>
-        </p:spPr>
-        <p:txBody>
-          <a:bodyPr wrap="none" anchor="t" lIns="0" rIns="0" tIns="0" bIns="0">
-            <a:noAutofit/>
-          </a:bodyPr>
-          <a:lstStyle/>
-          <a:p>
-            <a:pPr algn="ctr"/>
-            <a:r>
-              <a:rPr sz="8250" b="1" i="0">
-                <a:solidFill>
-                  <a:srgbClr val="B8FF00"/>
-                </a:solidFill>
-                <a:effectLst>
-                  <a:outerShdw blurRad="342900" dist="76200" dir="5400000" rotWithShape="0">
-                    <a:srgbClr val="000000">
-                      <a:alpha val="53333"/>
-                    </a:srgbClr>
-                  </a:outerShdw>
-                </a:effectLst>
-                <a:latin typeface="Roboto"/>
-              </a:rPr>
-              <a:t>QUARTERLY REVIEW</a:t>
-            </a:r>
-          </a:p>
-        </p:txBody>
-      </p:sp>
-      <p:sp>
-        <p:nvSpPr>
           <p:cNvPr id="4" name="Rounded Rectangle 3"/>
           <p:cNvSpPr/>
           <p:nvPr/>
         </p:nvSpPr>
         <p:spPr>
           <a:xfrm>
-            <a:off x="4305300" y="4029075"/>
-            <a:ext cx="171450" cy="171450"/>
+            <a:off x="971550" y="2057400"/>
+            <a:ext cx="685800" cy="76200"/>
           </a:xfrm>
           <a:prstGeom prst="roundRect">
             <a:avLst>
@@ -3194,7 +3206,7 @@
             </a:avLst>
           </a:prstGeom>
           <a:solidFill>
-            <a:srgbClr val="8CE1FF"/>
+            <a:srgbClr val="B8FF00"/>
           </a:solidFill>
           <a:ln>
             <a:noFill/>
@@ -3231,8 +3243,8 @@
         </p:nvSpPr>
         <p:spPr>
           <a:xfrm>
-            <a:off x="4629150" y="3952875"/>
-            <a:ext cx="3257550" cy="333375"/>
+            <a:off x="971550" y="2400300"/>
+            <a:ext cx="5162550" cy="219075"/>
           </a:xfrm>
           <a:prstGeom prst="rect">
             <a:avLst/>
@@ -3247,13 +3259,133 @@
           <a:p>
             <a:pPr algn="l"/>
             <a:r>
-              <a:rPr sz="3000" b="0" i="0">
+              <a:rPr sz="2100" b="1" i="0">
                 <a:solidFill>
-                  <a:srgbClr val="8CE1FF"/>
+                  <a:srgbClr val="7DD3FC"/>
                 </a:solidFill>
                 <a:latin typeface="Roboto"/>
               </a:rPr>
-              <a:t>FY25 · Q3 · Product</a:t>
+              <a:t>QUARTERLY BUSINESS REVIEW</a:t>
+            </a:r>
+          </a:p>
+        </p:txBody>
+      </p:sp>
+      <p:sp>
+        <p:nvSpPr>
+          <p:cNvPr id="6" name="TextBox 5"/>
+          <p:cNvSpPr txBox="1"/>
+          <p:nvPr/>
+        </p:nvSpPr>
+        <p:spPr>
+          <a:xfrm>
+            <a:off x="971550" y="3086100"/>
+            <a:ext cx="7086600" cy="1924050"/>
+          </a:xfrm>
+          <a:prstGeom prst="rect">
+            <a:avLst/>
+          </a:prstGeom>
+          <a:noFill/>
+        </p:spPr>
+        <p:txBody>
+          <a:bodyPr wrap="none" anchor="t" lIns="0" rIns="0" tIns="0" bIns="0">
+            <a:noAutofit/>
+          </a:bodyPr>
+          <a:lstStyle/>
+          <a:p>
+            <a:pPr algn="l">
+              <a:lnSpc>
+                <a:spcPts val="7650"/>
+              </a:lnSpc>
+            </a:pPr>
+            <a:r>
+              <a:rPr sz="7800" b="1" i="0">
+                <a:gradFill rotWithShape="1">
+                  <a:gsLst>
+                    <a:gs pos="0">
+                      <a:srgbClr val="B7FE00"/>
+                    </a:gs>
+                    <a:gs pos="100000">
+                      <a:srgbClr val="7DD3FB"/>
+                    </a:gs>
+                  </a:gsLst>
+                  <a:lin ang="1200000" scaled="0"/>
+                </a:gradFill>
+                <a:effectLst>
+                  <a:outerShdw blurRad="419100" dist="95250" dir="5400000" rotWithShape="0">
+                    <a:srgbClr val="000000">
+                      <a:alpha val="40000"/>
+                    </a:srgbClr>
+                  </a:outerShdw>
+                </a:effectLst>
+                <a:latin typeface="Roboto"/>
+              </a:rPr>
+              <a:t>Building what</a:t>
+            </a:r>
+          </a:p>
+          <a:p>
+            <a:pPr algn="l">
+              <a:lnSpc>
+                <a:spcPts val="7650"/>
+              </a:lnSpc>
+            </a:pPr>
+            <a:r>
+              <a:rPr sz="7800" b="1" i="0">
+                <a:gradFill rotWithShape="1">
+                  <a:gsLst>
+                    <a:gs pos="0">
+                      <a:srgbClr val="B7FE00"/>
+                    </a:gs>
+                    <a:gs pos="100000">
+                      <a:srgbClr val="7DD3FB"/>
+                    </a:gs>
+                  </a:gsLst>
+                  <a:lin ang="1200000" scaled="0"/>
+                </a:gradFill>
+                <a:effectLst>
+                  <a:outerShdw blurRad="419100" dist="95250" dir="5400000" rotWithShape="0">
+                    <a:srgbClr val="000000">
+                      <a:alpha val="40000"/>
+                    </a:srgbClr>
+                  </a:outerShdw>
+                </a:effectLst>
+                <a:latin typeface="Roboto"/>
+              </a:rPr>
+              <a:t>actually matters</a:t>
+            </a:r>
+          </a:p>
+        </p:txBody>
+      </p:sp>
+      <p:sp>
+        <p:nvSpPr>
+          <p:cNvPr id="7" name="TextBox 6"/>
+          <p:cNvSpPr txBox="1"/>
+          <p:nvPr/>
+        </p:nvSpPr>
+        <p:spPr>
+          <a:xfrm>
+            <a:off x="971550" y="5619750"/>
+            <a:ext cx="4486275" cy="285750"/>
+          </a:xfrm>
+          <a:prstGeom prst="rect">
+            <a:avLst/>
+          </a:prstGeom>
+          <a:noFill/>
+        </p:spPr>
+        <p:txBody>
+          <a:bodyPr wrap="none" anchor="t" lIns="0" rIns="0" tIns="0" bIns="0">
+            <a:noAutofit/>
+          </a:bodyPr>
+          <a:lstStyle/>
+          <a:p>
+            <a:pPr algn="l"/>
+            <a:r>
+              <a:rPr sz="2550" b="0" i="0">
+                <a:solidFill>
+                  <a:srgbClr val="8FA3B8"/>
+                </a:solidFill>
+                <a:latin typeface="Roboto"/>
+              </a:rPr>
+              <a:t>FY25  ·  Q3  ·  Product &amp; Growth</a:t>
             </a:r>
           </a:p>
         </p:txBody>
@@ -3287,7 +3419,7 @@
                             </p:stCondLst>
                             <p:childTnLst>
                               <p:par>
-                                <p:cTn id="5" presetID="10" presetClass="entr" presetSubtype="0" fill="hold" grpId="0" nodeType="clickEffect">
+                                <p:cTn id="5" presetID="22" presetClass="entr" presetSubtype="0" fill="hold" grpId="0" nodeType="clickEffect">
                                   <p:stCondLst>
                                     <p:cond delay="0"/>
                                   </p:stCondLst>
@@ -3300,7 +3432,7 @@
                                           </p:stCondLst>
                                         </p:cTn>
                                         <p:tgtEl>
-                                          <p:spTgt spid="3"/>
+                                          <p:spTgt spid="4"/>
                                         </p:tgtEl>
                                         <p:attrNameLst>
                                           <p:attrName>style.visibility</p:attrName>
@@ -3310,11 +3442,11 @@
                                         <p:strVal val="visible"/>
                                       </p:to>
                                     </p:set>
-                                    <p:animEffect transition="in" filter="fade">
+                                    <p:animEffect transition="in" filter="wipe(left)">
                                       <p:cBhvr>
-                                        <p:cTn id="7" dur="600"/>
+                                        <p:cTn id="7" dur="400"/>
                                         <p:tgtEl>
-                                          <p:spTgt spid="3"/>
+                                          <p:spTgt spid="4"/>
                                         </p:tgtEl>
                                       </p:cBhvr>
                                     </p:animEffect>
@@ -3340,7 +3472,7 @@
                             </p:stCondLst>
                             <p:childTnLst>
                               <p:par>
-                                <p:cTn id="10" presetID="21" presetClass="entr" presetSubtype="0" fill="hold" grpId="0" nodeType="afterEffect">
+                                <p:cTn id="10" presetID="10" presetClass="entr" presetSubtype="0" fill="hold" grpId="0" nodeType="afterEffect">
                                   <p:stCondLst>
                                     <p:cond delay="0"/>
                                   </p:stCondLst>
@@ -3348,32 +3480,6 @@
                                     <p:set>
                                       <p:cBhvr>
                                         <p:cTn id="11" dur="1" fill="hold">
-                                          <p:stCondLst>
-                                            <p:cond delay="0"/>
-                                          </p:stCondLst>
-                                        </p:cTn>
-                                        <p:tgtEl>
-                                          <p:spTgt spid="4"/>
-                                        </p:tgtEl>
-                                        <p:attrNameLst>
-                                          <p:attrName>style.visibility</p:attrName>
-                                        </p:attrNameLst>
-                                      </p:cBhvr>
-                                      <p:to>
-                                        <p:strVal val="visible"/>
-                                      </p:to>
-                                    </p:set>
-                                    <p:animEffect transition="in" filter="wheel(4)">
-                                      <p:cBhvr>
-                                        <p:cTn id="12" dur="500"/>
-                                        <p:tgtEl>
-                                          <p:spTgt spid="4"/>
-                                        </p:tgtEl>
-                                      </p:cBhvr>
-                                    </p:animEffect>
-                                    <p:set>
-                                      <p:cBhvr>
-                                        <p:cTn id="13" dur="1" fill="hold">
                                           <p:stCondLst>
                                             <p:cond delay="0"/>
                                           </p:stCondLst>
@@ -3389,11 +3495,117 @@
                                         <p:strVal val="visible"/>
                                       </p:to>
                                     </p:set>
-                                    <p:animEffect transition="in" filter="wheel(4)">
+                                    <p:animEffect transition="in" filter="fade">
                                       <p:cBhvr>
-                                        <p:cTn id="14" dur="500"/>
+                                        <p:cTn id="12" dur="500"/>
                                         <p:tgtEl>
                                           <p:spTgt spid="5"/>
+                                        </p:tgtEl>
+                                      </p:cBhvr>
+                                    </p:animEffect>
+                                  </p:childTnLst>
+                                </p:cTn>
+                              </p:par>
+                            </p:childTnLst>
+                          </p:cTn>
+                        </p:par>
+                      </p:childTnLst>
+                    </p:cTn>
+                  </p:par>
+                  <p:par>
+                    <p:cTn id="13" fill="hold">
+                      <p:stCondLst>
+                        <p:cond delay="0"/>
+                      </p:stCondLst>
+                      <p:childTnLst>
+                        <p:par>
+                          <p:cTn id="14" fill="hold">
+                            <p:stCondLst>
+                              <p:cond delay="0"/>
+                            </p:stCondLst>
+                            <p:childTnLst>
+                              <p:par>
+                                <p:cTn id="15" presetID="10" presetClass="entr" presetSubtype="0" fill="hold" grpId="0" nodeType="afterEffect">
+                                  <p:stCondLst>
+                                    <p:cond delay="0"/>
+                                  </p:stCondLst>
+                                  <p:childTnLst>
+                                    <p:set>
+                                      <p:cBhvr>
+                                        <p:cTn id="16" dur="1" fill="hold">
+                                          <p:stCondLst>
+                                            <p:cond delay="0"/>
+                                          </p:stCondLst>
+                                        </p:cTn>
+                                        <p:tgtEl>
+                                          <p:spTgt spid="6"/>
+                                        </p:tgtEl>
+                                        <p:attrNameLst>
+                                          <p:attrName>style.visibility</p:attrName>
+                                        </p:attrNameLst>
+                                      </p:cBhvr>
+                                      <p:to>
+                                        <p:strVal val="visible"/>
+                                      </p:to>
+                                    </p:set>
+                                    <p:animEffect transition="in" filter="fade">
+                                      <p:cBhvr>
+                                        <p:cTn id="17" dur="600"/>
+                                        <p:tgtEl>
+                                          <p:spTgt spid="6"/>
+                                        </p:tgtEl>
+                                      </p:cBhvr>
+                                    </p:animEffect>
+                                  </p:childTnLst>
+                                </p:cTn>
+                              </p:par>
+                            </p:childTnLst>
+                          </p:cTn>
+                        </p:par>
+                      </p:childTnLst>
+                    </p:cTn>
+                  </p:par>
+                  <p:par>
+                    <p:cTn id="18" fill="hold">
+                      <p:stCondLst>
+                        <p:cond delay="0"/>
+                      </p:stCondLst>
+                      <p:childTnLst>
+                        <p:par>
+                          <p:cTn id="19" fill="hold">
+                            <p:stCondLst>
+                              <p:cond delay="0"/>
+                            </p:stCondLst>
+                            <p:childTnLst>
+                              <p:par>
+                                <p:cTn id="20" presetID="10" presetClass="entr" presetSubtype="0" fill="hold" grpId="0" nodeType="afterEffect">
+                                  <p:stCondLst>
+                                    <p:cond delay="0"/>
+                                  </p:stCondLst>
+                                  <p:childTnLst>
+                                    <p:set>
+                                      <p:cBhvr>
+                                        <p:cTn id="21" dur="1" fill="hold">
+                                          <p:stCondLst>
+                                            <p:cond delay="0"/>
+                                          </p:stCondLst>
+                                        </p:cTn>
+                                        <p:tgtEl>
+                                          <p:spTgt spid="7"/>
+                                        </p:tgtEl>
+                                        <p:attrNameLst>
+                                          <p:attrName>style.visibility</p:attrName>
+                                        </p:attrNameLst>
+                                      </p:cBhvr>
+                                      <p:to>
+                                        <p:strVal val="visible"/>
+                                      </p:to>
+                                    </p:set>
+                                    <p:animEffect transition="in" filter="fade">
+                                      <p:cBhvr>
+                                        <p:cTn id="22" dur="500"/>
+                                        <p:tgtEl>
+                                          <p:spTgt spid="7"/>
                                         </p:tgtEl>
                                       </p:cBhvr>
                                     </p:animEffect>
@@ -3455,8 +3667,62 @@
           <a:prstGeom prst="rect">
             <a:avLst/>
           </a:prstGeom>
+          <a:gradFill rotWithShape="1">
+            <a:gsLst>
+              <a:gs pos="0">
+                <a:srgbClr val="0A1626"/>
+              </a:gs>
+              <a:gs pos="100000">
+                <a:srgbClr val="122849"/>
+              </a:gs>
+            </a:gsLst>
+            <a:lin ang="8100000" scaled="0"/>
+          </a:gradFill>
+          <a:ln>
+            <a:noFill/>
+          </a:ln>
+          <a:effectLst/>
+        </p:spPr>
+        <p:style>
+          <a:lnRef idx="1">
+            <a:schemeClr val="accent1"/>
+          </a:lnRef>
+          <a:fillRef idx="3">
+            <a:schemeClr val="accent1"/>
+          </a:fillRef>
+          <a:effectRef idx="2">
+            <a:schemeClr val="accent1"/>
+          </a:effectRef>
+          <a:fontRef idx="minor">
+            <a:schemeClr val="lt1"/>
+          </a:fontRef>
+        </p:style>
+        <p:txBody>
+          <a:bodyPr rtlCol="0" anchor="ctr"/>
+          <a:lstStyle/>
+          <a:p>
+            <a:pPr algn="ctr"/>
+          </a:p>
+        </p:txBody>
+      </p:sp>
+      <p:sp>
+        <p:nvSpPr>
+          <p:cNvPr id="3" name="Rounded Rectangle 2"/>
+          <p:cNvSpPr/>
+          <p:nvPr/>
+        </p:nvSpPr>
+        <p:spPr>
+          <a:xfrm>
+            <a:off x="971550" y="1028700"/>
+            <a:ext cx="685800" cy="76200"/>
+          </a:xfrm>
+          <a:prstGeom prst="roundRect">
+            <a:avLst>
+              <a:gd name="adj" fmla="val 50000"/>
+            </a:avLst>
+          </a:prstGeom>
           <a:solidFill>
-            <a:srgbClr val="0B1B2B"/>
+            <a:srgbClr val="B8FF00"/>
           </a:solidFill>
           <a:ln>
             <a:noFill/>
@@ -3487,13 +3753,13 @@
       </p:sp>
       <p:sp>
         <p:nvSpPr>
-          <p:cNvPr id="3" name="TextBox 2"/>
+          <p:cNvPr id="4" name="TextBox 3"/>
           <p:cNvSpPr txBox="1"/>
           <p:nvPr/>
         </p:nvSpPr>
         <p:spPr>
           <a:xfrm>
-            <a:off x="971550" y="1095375"/>
+            <a:off x="971550" y="1295400"/>
             <a:ext cx="2333625" cy="657225"/>
           </a:xfrm>
           <a:prstGeom prst="rect">
@@ -3511,7 +3777,7 @@
             <a:r>
               <a:rPr sz="5400" b="1" i="0">
                 <a:solidFill>
-                  <a:srgbClr val="FFFFFF"/>
+                  <a:srgbClr val="F8FAFC"/>
                 </a:solidFill>
                 <a:latin typeface="Roboto"/>
               </a:rPr>
@@ -3522,23 +3788,729 @@
       </p:sp>
       <p:sp>
         <p:nvSpPr>
-          <p:cNvPr id="4" name="Rounded Rectangle 3"/>
+          <p:cNvPr id="5" name="TextBox 4"/>
+          <p:cNvSpPr txBox="1"/>
+          <p:nvPr/>
+        </p:nvSpPr>
+        <p:spPr>
+          <a:xfrm>
+            <a:off x="1095375" y="2543175"/>
+            <a:ext cx="600075" cy="400050"/>
+          </a:xfrm>
+          <a:prstGeom prst="rect">
+            <a:avLst/>
+          </a:prstGeom>
+          <a:noFill/>
+        </p:spPr>
+        <p:txBody>
+          <a:bodyPr wrap="none" anchor="t" lIns="0" rIns="0" tIns="0" bIns="0">
+            <a:noAutofit/>
+          </a:bodyPr>
+          <a:lstStyle/>
+          <a:p>
+            <a:pPr algn="l"/>
+            <a:r>
+              <a:rPr sz="4200" b="1" i="0">
+                <a:solidFill>
+                  <a:srgbClr val="B8FF00"/>
+                </a:solidFill>
+                <a:latin typeface="Roboto"/>
+              </a:rPr>
+              <a:t>01</a:t>
+            </a:r>
+          </a:p>
+        </p:txBody>
+      </p:sp>
+      <p:sp>
+        <p:nvSpPr>
+          <p:cNvPr id="6" name="TextBox 5"/>
+          <p:cNvSpPr txBox="1"/>
+          <p:nvPr/>
+        </p:nvSpPr>
+        <p:spPr>
+          <a:xfrm>
+            <a:off x="2076450" y="2505075"/>
+            <a:ext cx="3962400" cy="476250"/>
+          </a:xfrm>
+          <a:prstGeom prst="rect">
+            <a:avLst/>
+          </a:prstGeom>
+          <a:noFill/>
+        </p:spPr>
+        <p:txBody>
+          <a:bodyPr wrap="none" anchor="t" lIns="0" rIns="0" tIns="0" bIns="0">
+            <a:noAutofit/>
+          </a:bodyPr>
+          <a:lstStyle/>
+          <a:p>
+            <a:pPr algn="l"/>
+            <a:r>
+              <a:rPr sz="3900" b="0" i="0">
+                <a:solidFill>
+                  <a:srgbClr val="F8FAFC"/>
+                </a:solidFill>
+                <a:latin typeface="Roboto"/>
+              </a:rPr>
+              <a:t>Revenue &amp; growth</a:t>
+            </a:r>
+          </a:p>
+        </p:txBody>
+      </p:sp>
+      <p:sp>
+        <p:nvSpPr>
+          <p:cNvPr id="7" name="TextBox 6"/>
+          <p:cNvSpPr txBox="1"/>
+          <p:nvPr/>
+        </p:nvSpPr>
+        <p:spPr>
+          <a:xfrm>
+            <a:off x="1095375" y="3495675"/>
+            <a:ext cx="600075" cy="400050"/>
+          </a:xfrm>
+          <a:prstGeom prst="rect">
+            <a:avLst/>
+          </a:prstGeom>
+          <a:noFill/>
+        </p:spPr>
+        <p:txBody>
+          <a:bodyPr wrap="none" anchor="t" lIns="0" rIns="0" tIns="0" bIns="0">
+            <a:noAutofit/>
+          </a:bodyPr>
+          <a:lstStyle/>
+          <a:p>
+            <a:pPr algn="l"/>
+            <a:r>
+              <a:rPr sz="4200" b="1" i="0">
+                <a:solidFill>
+                  <a:srgbClr val="B8FF00"/>
+                </a:solidFill>
+                <a:latin typeface="Roboto"/>
+              </a:rPr>
+              <a:t>02</a:t>
+            </a:r>
+          </a:p>
+        </p:txBody>
+      </p:sp>
+      <p:sp>
+        <p:nvSpPr>
+          <p:cNvPr id="8" name="TextBox 7"/>
+          <p:cNvSpPr txBox="1"/>
+          <p:nvPr/>
+        </p:nvSpPr>
+        <p:spPr>
+          <a:xfrm>
+            <a:off x="2076450" y="3457575"/>
+            <a:ext cx="3771900" cy="476250"/>
+          </a:xfrm>
+          <a:prstGeom prst="rect">
+            <a:avLst/>
+          </a:prstGeom>
+          <a:noFill/>
+        </p:spPr>
+        <p:txBody>
+          <a:bodyPr wrap="none" anchor="t" lIns="0" rIns="0" tIns="0" bIns="0">
+            <a:noAutofit/>
+          </a:bodyPr>
+          <a:lstStyle/>
+          <a:p>
+            <a:pPr algn="l"/>
+            <a:r>
+              <a:rPr sz="3900" b="0" i="0">
+                <a:solidFill>
+                  <a:srgbClr val="F8FAFC"/>
+                </a:solidFill>
+                <a:latin typeface="Roboto"/>
+              </a:rPr>
+              <a:t>What we shipped</a:t>
+            </a:r>
+          </a:p>
+        </p:txBody>
+      </p:sp>
+      <p:sp>
+        <p:nvSpPr>
+          <p:cNvPr id="9" name="TextBox 8"/>
+          <p:cNvSpPr txBox="1"/>
+          <p:nvPr/>
+        </p:nvSpPr>
+        <p:spPr>
+          <a:xfrm>
+            <a:off x="1095375" y="4457700"/>
+            <a:ext cx="600075" cy="400050"/>
+          </a:xfrm>
+          <a:prstGeom prst="rect">
+            <a:avLst/>
+          </a:prstGeom>
+          <a:noFill/>
+        </p:spPr>
+        <p:txBody>
+          <a:bodyPr wrap="none" anchor="t" lIns="0" rIns="0" tIns="0" bIns="0">
+            <a:noAutofit/>
+          </a:bodyPr>
+          <a:lstStyle/>
+          <a:p>
+            <a:pPr algn="l"/>
+            <a:r>
+              <a:rPr sz="4200" b="1" i="0">
+                <a:solidFill>
+                  <a:srgbClr val="B8FF00"/>
+                </a:solidFill>
+                <a:latin typeface="Roboto"/>
+              </a:rPr>
+              <a:t>03</a:t>
+            </a:r>
+          </a:p>
+        </p:txBody>
+      </p:sp>
+      <p:sp>
+        <p:nvSpPr>
+          <p:cNvPr id="10" name="TextBox 9"/>
+          <p:cNvSpPr txBox="1"/>
+          <p:nvPr/>
+        </p:nvSpPr>
+        <p:spPr>
+          <a:xfrm>
+            <a:off x="2076450" y="4467225"/>
+            <a:ext cx="3657600" cy="381000"/>
+          </a:xfrm>
+          <a:prstGeom prst="rect">
+            <a:avLst/>
+          </a:prstGeom>
+          <a:noFill/>
+        </p:spPr>
+        <p:txBody>
+          <a:bodyPr wrap="none" anchor="t" lIns="0" rIns="0" tIns="0" bIns="0">
+            <a:noAutofit/>
+          </a:bodyPr>
+          <a:lstStyle/>
+          <a:p>
+            <a:pPr algn="l"/>
+            <a:r>
+              <a:rPr sz="3900" b="0" i="0">
+                <a:solidFill>
+                  <a:srgbClr val="F8FAFC"/>
+                </a:solidFill>
+                <a:latin typeface="Roboto"/>
+              </a:rPr>
+              <a:t>What we learned</a:t>
+            </a:r>
+          </a:p>
+        </p:txBody>
+      </p:sp>
+      <p:sp>
+        <p:nvSpPr>
+          <p:cNvPr id="11" name="TextBox 10"/>
+          <p:cNvSpPr txBox="1"/>
+          <p:nvPr/>
+        </p:nvSpPr>
+        <p:spPr>
+          <a:xfrm>
+            <a:off x="1095375" y="5419725"/>
+            <a:ext cx="600075" cy="400050"/>
+          </a:xfrm>
+          <a:prstGeom prst="rect">
+            <a:avLst/>
+          </a:prstGeom>
+          <a:noFill/>
+        </p:spPr>
+        <p:txBody>
+          <a:bodyPr wrap="none" anchor="t" lIns="0" rIns="0" tIns="0" bIns="0">
+            <a:noAutofit/>
+          </a:bodyPr>
+          <a:lstStyle/>
+          <a:p>
+            <a:pPr algn="l"/>
+            <a:r>
+              <a:rPr sz="4200" b="1" i="0">
+                <a:solidFill>
+                  <a:srgbClr val="B8FF00"/>
+                </a:solidFill>
+                <a:latin typeface="Roboto"/>
+              </a:rPr>
+              <a:t>04</a:t>
+            </a:r>
+          </a:p>
+        </p:txBody>
+      </p:sp>
+      <p:sp>
+        <p:nvSpPr>
+          <p:cNvPr id="12" name="TextBox 11"/>
+          <p:cNvSpPr txBox="1"/>
+          <p:nvPr/>
+        </p:nvSpPr>
+        <p:spPr>
+          <a:xfrm>
+            <a:off x="2076450" y="5381625"/>
+            <a:ext cx="3905250" cy="476250"/>
+          </a:xfrm>
+          <a:prstGeom prst="rect">
+            <a:avLst/>
+          </a:prstGeom>
+          <a:noFill/>
+        </p:spPr>
+        <p:txBody>
+          <a:bodyPr wrap="none" anchor="t" lIns="0" rIns="0" tIns="0" bIns="0">
+            <a:noAutofit/>
+          </a:bodyPr>
+          <a:lstStyle/>
+          <a:p>
+            <a:pPr algn="l"/>
+            <a:r>
+              <a:rPr sz="3900" b="0" i="0">
+                <a:solidFill>
+                  <a:srgbClr val="F8FAFC"/>
+                </a:solidFill>
+                <a:latin typeface="Roboto"/>
+              </a:rPr>
+              <a:t>Where we go next</a:t>
+            </a:r>
+          </a:p>
+        </p:txBody>
+      </p:sp>
+    </p:spTree>
+  </p:cSld>
+  <p:clrMapOvr>
+    <a:masterClrMapping/>
+  </p:clrMapOvr>
+  <p:transition xmlns:p14="http://schemas.microsoft.com/office/powerpoint/2010/main" spd="fast" advClick="1" p14:dur="400">
+    <p:fade/>
+  </p:transition>
+  <p:timing>
+    <p:tnLst>
+      <p:par>
+        <p:cTn id="1" dur="indefinite" restart="never" nodeType="tmRoot">
+          <p:childTnLst>
+            <p:seq concurrent="1" nextAc="seek">
+              <p:cTn id="2" dur="indefinite" nodeType="mainSeq">
+                <p:childTnLst>
+                  <p:par>
+                    <p:cTn id="3" fill="hold">
+                      <p:stCondLst>
+                        <p:cond delay="indefinite"/>
+                      </p:stCondLst>
+                      <p:childTnLst>
+                        <p:par>
+                          <p:cTn id="4" fill="hold">
+                            <p:stCondLst>
+                              <p:cond delay="0"/>
+                            </p:stCondLst>
+                            <p:childTnLst>
+                              <p:par>
+                                <p:cTn id="5" presetID="10" presetClass="entr" presetSubtype="0" fill="hold" grpId="0" nodeType="clickEffect">
+                                  <p:stCondLst>
+                                    <p:cond delay="0"/>
+                                  </p:stCondLst>
+                                  <p:childTnLst>
+                                    <p:set>
+                                      <p:cBhvr>
+                                        <p:cTn id="6" dur="1" fill="hold">
+                                          <p:stCondLst>
+                                            <p:cond delay="0"/>
+                                          </p:stCondLst>
+                                        </p:cTn>
+                                        <p:tgtEl>
+                                          <p:spTgt spid="4"/>
+                                        </p:tgtEl>
+                                        <p:attrNameLst>
+                                          <p:attrName>style.visibility</p:attrName>
+                                        </p:attrNameLst>
+                                      </p:cBhvr>
+                                      <p:to>
+                                        <p:strVal val="visible"/>
+                                      </p:to>
+                                    </p:set>
+                                    <p:animEffect transition="in" filter="fade">
+                                      <p:cBhvr>
+                                        <p:cTn id="7" dur="500"/>
+                                        <p:tgtEl>
+                                          <p:spTgt spid="4"/>
+                                        </p:tgtEl>
+                                      </p:cBhvr>
+                                    </p:animEffect>
+                                  </p:childTnLst>
+                                </p:cTn>
+                              </p:par>
+                            </p:childTnLst>
+                          </p:cTn>
+                        </p:par>
+                      </p:childTnLst>
+                    </p:cTn>
+                  </p:par>
+                  <p:par>
+                    <p:cTn id="8" fill="hold">
+                      <p:stCondLst>
+                        <p:cond delay="indefinite"/>
+                      </p:stCondLst>
+                      <p:childTnLst>
+                        <p:par>
+                          <p:cTn id="9" fill="hold">
+                            <p:stCondLst>
+                              <p:cond delay="0"/>
+                            </p:stCondLst>
+                            <p:childTnLst>
+                              <p:par>
+                                <p:cTn id="10" presetID="22" presetClass="entr" presetSubtype="0" fill="hold" grpId="0" nodeType="clickEffect">
+                                  <p:stCondLst>
+                                    <p:cond delay="0"/>
+                                  </p:stCondLst>
+                                  <p:childTnLst>
+                                    <p:set>
+                                      <p:cBhvr>
+                                        <p:cTn id="11" dur="1" fill="hold">
+                                          <p:stCondLst>
+                                            <p:cond delay="0"/>
+                                          </p:stCondLst>
+                                        </p:cTn>
+                                        <p:tgtEl>
+                                          <p:spTgt spid="5"/>
+                                        </p:tgtEl>
+                                        <p:attrNameLst>
+                                          <p:attrName>style.visibility</p:attrName>
+                                        </p:attrNameLst>
+                                      </p:cBhvr>
+                                      <p:to>
+                                        <p:strVal val="visible"/>
+                                      </p:to>
+                                    </p:set>
+                                    <p:animEffect transition="in" filter="wipe(left)">
+                                      <p:cBhvr>
+                                        <p:cTn id="12" dur="400"/>
+                                        <p:tgtEl>
+                                          <p:spTgt spid="5"/>
+                                        </p:tgtEl>
+                                      </p:cBhvr>
+                                    </p:animEffect>
+                                    <p:set>
+                                      <p:cBhvr>
+                                        <p:cTn id="13" dur="1" fill="hold">
+                                          <p:stCondLst>
+                                            <p:cond delay="0"/>
+                                          </p:stCondLst>
+                                        </p:cTn>
+                                        <p:tgtEl>
+                                          <p:spTgt spid="6"/>
+                                        </p:tgtEl>
+                                        <p:attrNameLst>
+                                          <p:attrName>style.visibility</p:attrName>
+                                        </p:attrNameLst>
+                                      </p:cBhvr>
+                                      <p:to>
+                                        <p:strVal val="visible"/>
+                                      </p:to>
+                                    </p:set>
+                                    <p:animEffect transition="in" filter="wipe(left)">
+                                      <p:cBhvr>
+                                        <p:cTn id="14" dur="400"/>
+                                        <p:tgtEl>
+                                          <p:spTgt spid="6"/>
+                                        </p:tgtEl>
+                                      </p:cBhvr>
+                                    </p:animEffect>
+                                  </p:childTnLst>
+                                </p:cTn>
+                              </p:par>
+                            </p:childTnLst>
+                          </p:cTn>
+                        </p:par>
+                      </p:childTnLst>
+                    </p:cTn>
+                  </p:par>
+                  <p:par>
+                    <p:cTn id="15" fill="hold">
+                      <p:stCondLst>
+                        <p:cond delay="indefinite"/>
+                      </p:stCondLst>
+                      <p:childTnLst>
+                        <p:par>
+                          <p:cTn id="16" fill="hold">
+                            <p:stCondLst>
+                              <p:cond delay="0"/>
+                            </p:stCondLst>
+                            <p:childTnLst>
+                              <p:par>
+                                <p:cTn id="17" presetID="22" presetClass="entr" presetSubtype="0" fill="hold" grpId="0" nodeType="clickEffect">
+                                  <p:stCondLst>
+                                    <p:cond delay="0"/>
+                                  </p:stCondLst>
+                                  <p:childTnLst>
+                                    <p:set>
+                                      <p:cBhvr>
+                                        <p:cTn id="18" dur="1" fill="hold">
+                                          <p:stCondLst>
+                                            <p:cond delay="0"/>
+                                          </p:stCondLst>
+                                        </p:cTn>
+                                        <p:tgtEl>
+                                          <p:spTgt spid="7"/>
+                                        </p:tgtEl>
+                                        <p:attrNameLst>
+                                          <p:attrName>style.visibility</p:attrName>
+                                        </p:attrNameLst>
+                                      </p:cBhvr>
+                                      <p:to>
+                                        <p:strVal val="visible"/>
+                                      </p:to>
+                                    </p:set>
+                                    <p:animEffect transition="in" filter="wipe(left)">
+                                      <p:cBhvr>
+                                        <p:cTn id="19" dur="400"/>
+                                        <p:tgtEl>
+                                          <p:spTgt spid="7"/>
+                                        </p:tgtEl>
+                                      </p:cBhvr>
+                                    </p:animEffect>
+                                    <p:set>
+                                      <p:cBhvr>
+                                        <p:cTn id="20" dur="1" fill="hold">
+                                          <p:stCondLst>
+                                            <p:cond delay="0"/>
+                                          </p:stCondLst>
+                                        </p:cTn>
+                                        <p:tgtEl>
+                                          <p:spTgt spid="8"/>
+                                        </p:tgtEl>
+                                        <p:attrNameLst>
+                                          <p:attrName>style.visibility</p:attrName>
+                                        </p:attrNameLst>
+                                      </p:cBhvr>
+                                      <p:to>
+                                        <p:strVal val="visible"/>
+                                      </p:to>
+                                    </p:set>
+                                    <p:animEffect transition="in" filter="wipe(left)">
+                                      <p:cBhvr>
+                                        <p:cTn id="21" dur="400"/>
+                                        <p:tgtEl>
+                                          <p:spTgt spid="8"/>
+                                        </p:tgtEl>
+                                      </p:cBhvr>
+                                    </p:animEffect>
+                                  </p:childTnLst>
+                                </p:cTn>
+                              </p:par>
+                            </p:childTnLst>
+                          </p:cTn>
+                        </p:par>
+                      </p:childTnLst>
+                    </p:cTn>
+                  </p:par>
+                  <p:par>
+                    <p:cTn id="22" fill="hold">
+                      <p:stCondLst>
+                        <p:cond delay="indefinite"/>
+                      </p:stCondLst>
+                      <p:childTnLst>
+                        <p:par>
+                          <p:cTn id="23" fill="hold">
+                            <p:stCondLst>
+                              <p:cond delay="0"/>
+                            </p:stCondLst>
+                            <p:childTnLst>
+                              <p:par>
+                                <p:cTn id="24" presetID="22" presetClass="entr" presetSubtype="0" fill="hold" grpId="0" nodeType="clickEffect">
+                                  <p:stCondLst>
+                                    <p:cond delay="0"/>
+                                  </p:stCondLst>
+                                  <p:childTnLst>
+                                    <p:set>
+                                      <p:cBhvr>
+                                        <p:cTn id="25" dur="1" fill="hold">
+                                          <p:stCondLst>
+                                            <p:cond delay="0"/>
+                                          </p:stCondLst>
+                                        </p:cTn>
+                                        <p:tgtEl>
+                                          <p:spTgt spid="9"/>
+                                        </p:tgtEl>
+                                        <p:attrNameLst>
+                                          <p:attrName>style.visibility</p:attrName>
+                                        </p:attrNameLst>
+                                      </p:cBhvr>
+                                      <p:to>
+                                        <p:strVal val="visible"/>
+                                      </p:to>
+                                    </p:set>
+                                    <p:animEffect transition="in" filter="wipe(left)">
+                                      <p:cBhvr>
+                                        <p:cTn id="26" dur="400"/>
+                                        <p:tgtEl>
+                                          <p:spTgt spid="9"/>
+                                        </p:tgtEl>
+                                      </p:cBhvr>
+                                    </p:animEffect>
+                                    <p:set>
+                                      <p:cBhvr>
+                                        <p:cTn id="27" dur="1" fill="hold">
+                                          <p:stCondLst>
+                                            <p:cond delay="0"/>
+                                          </p:stCondLst>
+                                        </p:cTn>
+                                        <p:tgtEl>
+                                          <p:spTgt spid="10"/>
+                                        </p:tgtEl>
+                                        <p:attrNameLst>
+                                          <p:attrName>style.visibility</p:attrName>
+                                        </p:attrNameLst>
+                                      </p:cBhvr>
+                                      <p:to>
+                                        <p:strVal val="visible"/>
+                                      </p:to>
+                                    </p:set>
+                                    <p:animEffect transition="in" filter="wipe(left)">
+                                      <p:cBhvr>
+                                        <p:cTn id="28" dur="400"/>
+                                        <p:tgtEl>
+                                          <p:spTgt spid="10"/>
+                                        </p:tgtEl>
+                                      </p:cBhvr>
+                                    </p:animEffect>
+                                  </p:childTnLst>
+                                </p:cTn>
+                              </p:par>
+                            </p:childTnLst>
+                          </p:cTn>
+                        </p:par>
+                      </p:childTnLst>
+                    </p:cTn>
+                  </p:par>
+                  <p:par>
+                    <p:cTn id="29" fill="hold">
+                      <p:stCondLst>
+                        <p:cond delay="indefinite"/>
+                      </p:stCondLst>
+                      <p:childTnLst>
+                        <p:par>
+                          <p:cTn id="30" fill="hold">
+                            <p:stCondLst>
+                              <p:cond delay="0"/>
+                            </p:stCondLst>
+                            <p:childTnLst>
+                              <p:par>
+                                <p:cTn id="31" presetID="22" presetClass="entr" presetSubtype="0" fill="hold" grpId="0" nodeType="clickEffect">
+                                  <p:stCondLst>
+                                    <p:cond delay="0"/>
+                                  </p:stCondLst>
+                                  <p:childTnLst>
+                                    <p:set>
+                                      <p:cBhvr>
+                                        <p:cTn id="32" dur="1" fill="hold">
+                                          <p:stCondLst>
+                                            <p:cond delay="0"/>
+                                          </p:stCondLst>
+                                        </p:cTn>
+                                        <p:tgtEl>
+                                          <p:spTgt spid="11"/>
+                                        </p:tgtEl>
+                                        <p:attrNameLst>
+                                          <p:attrName>style.visibility</p:attrName>
+                                        </p:attrNameLst>
+                                      </p:cBhvr>
+                                      <p:to>
+                                        <p:strVal val="visible"/>
+                                      </p:to>
+                                    </p:set>
+                                    <p:animEffect transition="in" filter="wipe(left)">
+                                      <p:cBhvr>
+                                        <p:cTn id="33" dur="400"/>
+                                        <p:tgtEl>
+                                          <p:spTgt spid="11"/>
+                                        </p:tgtEl>
+                                      </p:cBhvr>
+                                    </p:animEffect>
+                                    <p:set>
+                                      <p:cBhvr>
+                                        <p:cTn id="34" dur="1" fill="hold">
+                                          <p:stCondLst>
+                                            <p:cond delay="0"/>
+                                          </p:stCondLst>
+                                        </p:cTn>
+                                        <p:tgtEl>
+                                          <p:spTgt spid="12"/>
+                                        </p:tgtEl>
+                                        <p:attrNameLst>
+                                          <p:attrName>style.visibility</p:attrName>
+                                        </p:attrNameLst>
+                                      </p:cBhvr>
+                                      <p:to>
+                                        <p:strVal val="visible"/>
+                                      </p:to>
+                                    </p:set>
+                                    <p:animEffect transition="in" filter="wipe(left)">
+                                      <p:cBhvr>
+                                        <p:cTn id="35" dur="400"/>
+                                        <p:tgtEl>
+                                          <p:spTgt spid="12"/>
+                                        </p:tgtEl>
+                                      </p:cBhvr>
+                                    </p:animEffect>
+                                  </p:childTnLst>
+                                </p:cTn>
+                              </p:par>
+                            </p:childTnLst>
+                          </p:cTn>
+                        </p:par>
+                      </p:childTnLst>
+                    </p:cTn>
+                  </p:par>
+                </p:childTnLst>
+              </p:cTn>
+              <p:prevCondLst>
+                <p:cond evt="onPrev" delay="0">
+                  <p:tgtEl>
+                    <p:sldTgt/>
+                  </p:tgtEl>
+                </p:cond>
+              </p:prevCondLst>
+              <p:nextCondLst>
+                <p:cond evt="onNext" delay="0">
+                  <p:tgtEl>
+                    <p:sldTgt/>
+                  </p:tgtEl>
+                </p:cond>
+              </p:nextCondLst>
+            </p:seq>
+          </p:childTnLst>
+        </p:cTn>
+      </p:par>
+    </p:tnLst>
+  </p:timing>
+</p:sld>
+</file>
+
+<file path=ppt/slides/slide3.xml><?xml version="1.0" encoding="utf-8"?>
+<p:sld xmlns:a="http://schemas.openxmlformats.org/drawingml/2006/main" xmlns:p="http://schemas.openxmlformats.org/presentationml/2006/main" xmlns:r="http://schemas.openxmlformats.org/officeDocument/2006/relationships">
+  <p:cSld>
+    <p:spTree>
+      <p:nvGrpSpPr>
+        <p:cNvPr id="1" name=""/>
+        <p:cNvGrpSpPr/>
+        <p:nvPr/>
+      </p:nvGrpSpPr>
+      <p:grpSpPr/>
+      <p:sp>
+        <p:nvSpPr>
+          <p:cNvPr id="2" name="Rectangle 1"/>
           <p:cNvSpPr/>
           <p:nvPr/>
         </p:nvSpPr>
         <p:spPr>
           <a:xfrm>
-            <a:off x="1028700" y="2505075"/>
-            <a:ext cx="4638675" cy="628650"/>
+            <a:off x="0" y="0"/>
+            <a:ext cx="12192000" cy="6858000"/>
           </a:xfrm>
-          <a:prstGeom prst="roundRect">
-            <a:avLst>
-              <a:gd name="adj" fmla="val 15151"/>
-            </a:avLst>
+          <a:prstGeom prst="rect">
+            <a:avLst/>
           </a:prstGeom>
-          <a:solidFill>
-            <a:srgbClr val="13314A"/>
-          </a:solidFill>
+          <a:gradFill rotWithShape="1">
+            <a:gsLst>
+              <a:gs pos="0">
+                <a:srgbClr val="07140C"/>
+              </a:gs>
+              <a:gs pos="100000">
+                <a:srgbClr val="0E291A"/>
+              </a:gs>
+            </a:gsLst>
+            <a:lin ang="8100000" scaled="0"/>
+          </a:gradFill>
           <a:ln>
             <a:noFill/>
           </a:ln>
@@ -3568,14 +4540,14 @@
       </p:sp>
       <p:sp>
         <p:nvSpPr>
-          <p:cNvPr id="5" name="TextBox 4"/>
+          <p:cNvPr id="3" name="TextBox 2"/>
           <p:cNvSpPr txBox="1"/>
           <p:nvPr/>
         </p:nvSpPr>
         <p:spPr>
           <a:xfrm>
-            <a:off x="1219200" y="2600325"/>
-            <a:ext cx="4257675" cy="438150"/>
+            <a:off x="3819525" y="1371600"/>
+            <a:ext cx="4562475" cy="276225"/>
           </a:xfrm>
           <a:prstGeom prst="rect">
             <a:avLst/>
@@ -3588,75 +4560,29 @@
           </a:bodyPr>
           <a:lstStyle/>
           <a:p>
-            <a:pPr algn="l"/>
-            <a:r>
-              <a:rPr sz="3600" b="0" i="0">
+            <a:pPr algn="ctr"/>
+            <a:r>
+              <a:rPr sz="2250" b="1" i="0">
                 <a:solidFill>
-                  <a:srgbClr val="8CE1FF"/>
+                  <a:srgbClr val="7DD3FC"/>
                 </a:solidFill>
                 <a:latin typeface="Roboto"/>
               </a:rPr>
-              <a:t>1.  Revenue &amp; growth</a:t>
-            </a:r>
-          </a:p>
-        </p:txBody>
-      </p:sp>
-      <p:sp>
-        <p:nvSpPr>
-          <p:cNvPr id="6" name="Rounded Rectangle 5"/>
-          <p:cNvSpPr/>
+              <a:t>Active teams, year over year</a:t>
+            </a:r>
+          </a:p>
+        </p:txBody>
+      </p:sp>
+      <p:sp>
+        <p:nvSpPr>
+          <p:cNvPr id="4" name="TextBox 3"/>
+          <p:cNvSpPr txBox="1"/>
           <p:nvPr/>
         </p:nvSpPr>
         <p:spPr>
           <a:xfrm>
-            <a:off x="1028700" y="3400425"/>
-            <a:ext cx="3771900" cy="628650"/>
-          </a:xfrm>
-          <a:prstGeom prst="roundRect">
-            <a:avLst>
-              <a:gd name="adj" fmla="val 15151"/>
-            </a:avLst>
-          </a:prstGeom>
-          <a:solidFill>
-            <a:srgbClr val="13314A"/>
-          </a:solidFill>
-          <a:ln>
-            <a:noFill/>
-          </a:ln>
-          <a:effectLst/>
-        </p:spPr>
-        <p:style>
-          <a:lnRef idx="1">
-            <a:schemeClr val="accent1"/>
-          </a:lnRef>
-          <a:fillRef idx="3">
-            <a:schemeClr val="accent1"/>
-          </a:fillRef>
-          <a:effectRef idx="2">
-            <a:schemeClr val="accent1"/>
-          </a:effectRef>
-          <a:fontRef idx="minor">
-            <a:schemeClr val="lt1"/>
-          </a:fontRef>
-        </p:style>
-        <p:txBody>
-          <a:bodyPr rtlCol="0" anchor="ctr"/>
-          <a:lstStyle/>
-          <a:p>
-            <a:pPr algn="ctr"/>
-          </a:p>
-        </p:txBody>
-      </p:sp>
-      <p:sp>
-        <p:nvSpPr>
-          <p:cNvPr id="7" name="TextBox 6"/>
-          <p:cNvSpPr txBox="1"/>
-          <p:nvPr/>
-        </p:nvSpPr>
-        <p:spPr>
-          <a:xfrm>
-            <a:off x="1219200" y="3495675"/>
-            <a:ext cx="3390900" cy="438150"/>
+            <a:off x="2628900" y="2352675"/>
+            <a:ext cx="6924675" cy="2085975"/>
           </a:xfrm>
           <a:prstGeom prst="rect">
             <a:avLst/>
@@ -3669,75 +4595,44 @@
           </a:bodyPr>
           <a:lstStyle/>
           <a:p>
-            <a:pPr algn="l"/>
-            <a:r>
-              <a:rPr sz="3600" b="0" i="0">
-                <a:solidFill>
-                  <a:srgbClr val="FFFFFF"/>
-                </a:solidFill>
+            <a:pPr algn="ctr"/>
+            <a:r>
+              <a:rPr sz="22500" b="1" i="0">
+                <a:gradFill rotWithShape="1">
+                  <a:gsLst>
+                    <a:gs pos="0">
+                      <a:srgbClr val="B7FE00"/>
+                    </a:gs>
+                    <a:gs pos="100000">
+                      <a:srgbClr val="5EEAD3"/>
+                    </a:gs>
+                  </a:gsLst>
+                  <a:lin ang="1200000" scaled="0"/>
+                </a:gradFill>
+                <a:effectLst>
+                  <a:outerShdw blurRad="419100" dist="95250" dir="5400000" rotWithShape="0">
+                    <a:srgbClr val="000000">
+                      <a:alpha val="40000"/>
+                    </a:srgbClr>
+                  </a:outerShdw>
+                </a:effectLst>
                 <a:latin typeface="Roboto"/>
               </a:rPr>
-              <a:t>2.  What shipped</a:t>
-            </a:r>
-          </a:p>
-        </p:txBody>
-      </p:sp>
-      <p:sp>
-        <p:nvSpPr>
-          <p:cNvPr id="8" name="Rounded Rectangle 7"/>
-          <p:cNvSpPr/>
+              <a:t>+38%</a:t>
+            </a:r>
+          </a:p>
+        </p:txBody>
+      </p:sp>
+      <p:sp>
+        <p:nvSpPr>
+          <p:cNvPr id="5" name="TextBox 4"/>
+          <p:cNvSpPr txBox="1"/>
           <p:nvPr/>
         </p:nvSpPr>
         <p:spPr>
           <a:xfrm>
-            <a:off x="1028700" y="4286250"/>
-            <a:ext cx="4362450" cy="533400"/>
-          </a:xfrm>
-          <a:prstGeom prst="roundRect">
-            <a:avLst>
-              <a:gd name="adj" fmla="val 17857"/>
-            </a:avLst>
-          </a:prstGeom>
-          <a:solidFill>
-            <a:srgbClr val="13314A"/>
-          </a:solidFill>
-          <a:ln>
-            <a:noFill/>
-          </a:ln>
-          <a:effectLst/>
-        </p:spPr>
-        <p:style>
-          <a:lnRef idx="1">
-            <a:schemeClr val="accent1"/>
-          </a:lnRef>
-          <a:fillRef idx="3">
-            <a:schemeClr val="accent1"/>
-          </a:fillRef>
-          <a:effectRef idx="2">
-            <a:schemeClr val="accent1"/>
-          </a:effectRef>
-          <a:fontRef idx="minor">
-            <a:schemeClr val="lt1"/>
-          </a:fontRef>
-        </p:style>
-        <p:txBody>
-          <a:bodyPr rtlCol="0" anchor="ctr"/>
-          <a:lstStyle/>
-          <a:p>
-            <a:pPr algn="ctr"/>
-          </a:p>
-        </p:txBody>
-      </p:sp>
-      <p:sp>
-        <p:nvSpPr>
-          <p:cNvPr id="9" name="TextBox 8"/>
-          <p:cNvSpPr txBox="1"/>
-          <p:nvPr/>
-        </p:nvSpPr>
-        <p:spPr>
-          <a:xfrm>
-            <a:off x="1219200" y="4381500"/>
-            <a:ext cx="3981450" cy="342900"/>
+            <a:off x="2305050" y="5410200"/>
+            <a:ext cx="1295400" cy="428625"/>
           </a:xfrm>
           <a:prstGeom prst="rect">
             <a:avLst/>
@@ -3752,73 +4647,27 @@
           <a:p>
             <a:pPr algn="l"/>
             <a:r>
-              <a:rPr sz="3600" b="0" i="0">
+              <a:rPr sz="4500" b="1" i="0">
                 <a:solidFill>
-                  <a:srgbClr val="8CE1FF"/>
+                  <a:srgbClr val="7DD3FC"/>
                 </a:solidFill>
                 <a:latin typeface="Roboto"/>
               </a:rPr>
-              <a:t>3.  What we learned</a:t>
-            </a:r>
-          </a:p>
-        </p:txBody>
-      </p:sp>
-      <p:sp>
-        <p:nvSpPr>
-          <p:cNvPr id="10" name="Rounded Rectangle 9"/>
-          <p:cNvSpPr/>
+              <a:t>2.4M</a:t>
+            </a:r>
+          </a:p>
+        </p:txBody>
+      </p:sp>
+      <p:sp>
+        <p:nvSpPr>
+          <p:cNvPr id="6" name="TextBox 5"/>
+          <p:cNvSpPr txBox="1"/>
           <p:nvPr/>
         </p:nvSpPr>
         <p:spPr>
           <a:xfrm>
-            <a:off x="1028700" y="5181600"/>
-            <a:ext cx="3514725" cy="609600"/>
-          </a:xfrm>
-          <a:prstGeom prst="roundRect">
-            <a:avLst>
-              <a:gd name="adj" fmla="val 15625"/>
-            </a:avLst>
-          </a:prstGeom>
-          <a:solidFill>
-            <a:srgbClr val="13314A"/>
-          </a:solidFill>
-          <a:ln>
-            <a:noFill/>
-          </a:ln>
-          <a:effectLst/>
-        </p:spPr>
-        <p:style>
-          <a:lnRef idx="1">
-            <a:schemeClr val="accent1"/>
-          </a:lnRef>
-          <a:fillRef idx="3">
-            <a:schemeClr val="accent1"/>
-          </a:fillRef>
-          <a:effectRef idx="2">
-            <a:schemeClr val="accent1"/>
-          </a:effectRef>
-          <a:fontRef idx="minor">
-            <a:schemeClr val="lt1"/>
-          </a:fontRef>
-        </p:style>
-        <p:txBody>
-          <a:bodyPr rtlCol="0" anchor="ctr"/>
-          <a:lstStyle/>
-          <a:p>
-            <a:pPr algn="ctr"/>
-          </a:p>
-        </p:txBody>
-      </p:sp>
-      <p:sp>
-        <p:nvSpPr>
-          <p:cNvPr id="11" name="TextBox 10"/>
-          <p:cNvSpPr txBox="1"/>
-          <p:nvPr/>
-        </p:nvSpPr>
-        <p:spPr>
-          <a:xfrm>
-            <a:off x="1219200" y="5276850"/>
-            <a:ext cx="3133725" cy="419100"/>
+            <a:off x="3810000" y="5476875"/>
+            <a:ext cx="1914525" cy="295275"/>
           </a:xfrm>
           <a:prstGeom prst="rect">
             <a:avLst/>
@@ -3833,13 +4682,118 @@
           <a:p>
             <a:pPr algn="l"/>
             <a:r>
-              <a:rPr sz="3600" b="0" i="0">
+              <a:rPr sz="2400" b="0" i="0">
                 <a:solidFill>
-                  <a:srgbClr val="FFFFFF"/>
+                  <a:srgbClr val="8FA3B8"/>
                 </a:solidFill>
                 <a:latin typeface="Roboto"/>
               </a:rPr>
-              <a:t>4.  Next quarter</a:t>
+              <a:t>monthly users</a:t>
+            </a:r>
+          </a:p>
+        </p:txBody>
+      </p:sp>
+      <p:sp>
+        <p:nvSpPr>
+          <p:cNvPr id="7" name="TextBox 6"/>
+          <p:cNvSpPr txBox="1"/>
+          <p:nvPr/>
+        </p:nvSpPr>
+        <p:spPr>
+          <a:xfrm>
+            <a:off x="5934075" y="5543550"/>
+            <a:ext cx="95250" cy="161925"/>
+          </a:xfrm>
+          <a:prstGeom prst="rect">
+            <a:avLst/>
+          </a:prstGeom>
+          <a:noFill/>
+        </p:spPr>
+        <p:txBody>
+          <a:bodyPr wrap="none" anchor="t" lIns="0" rIns="0" tIns="0" bIns="0">
+            <a:noAutofit/>
+          </a:bodyPr>
+          <a:lstStyle/>
+          <a:p>
+            <a:pPr algn="l"/>
+            <a:r>
+              <a:rPr sz="3000" b="0" i="0">
+                <a:solidFill>
+                  <a:srgbClr val="33506E"/>
+                </a:solidFill>
+                <a:latin typeface="Roboto"/>
+              </a:rPr>
+              <a:t>·</a:t>
+            </a:r>
+          </a:p>
+        </p:txBody>
+      </p:sp>
+      <p:sp>
+        <p:nvSpPr>
+          <p:cNvPr id="8" name="TextBox 7"/>
+          <p:cNvSpPr txBox="1"/>
+          <p:nvPr/>
+        </p:nvSpPr>
+        <p:spPr>
+          <a:xfrm>
+            <a:off x="6238875" y="5410200"/>
+            <a:ext cx="1285875" cy="428625"/>
+          </a:xfrm>
+          <a:prstGeom prst="rect">
+            <a:avLst/>
+          </a:prstGeom>
+          <a:noFill/>
+        </p:spPr>
+        <p:txBody>
+          <a:bodyPr wrap="none" anchor="t" lIns="0" rIns="0" tIns="0" bIns="0">
+            <a:noAutofit/>
+          </a:bodyPr>
+          <a:lstStyle/>
+          <a:p>
+            <a:pPr algn="l"/>
+            <a:r>
+              <a:rPr sz="4500" b="1" i="0">
+                <a:solidFill>
+                  <a:srgbClr val="7DD3FC"/>
+                </a:solidFill>
+                <a:latin typeface="Roboto"/>
+              </a:rPr>
+              <a:t>+120</a:t>
+            </a:r>
+          </a:p>
+        </p:txBody>
+      </p:sp>
+      <p:sp>
+        <p:nvSpPr>
+          <p:cNvPr id="9" name="TextBox 8"/>
+          <p:cNvSpPr txBox="1"/>
+          <p:nvPr/>
+        </p:nvSpPr>
+        <p:spPr>
+          <a:xfrm>
+            <a:off x="7734300" y="5476875"/>
+            <a:ext cx="2152650" cy="295275"/>
+          </a:xfrm>
+          <a:prstGeom prst="rect">
+            <a:avLst/>
+          </a:prstGeom>
+          <a:noFill/>
+        </p:spPr>
+        <p:txBody>
+          <a:bodyPr wrap="none" anchor="t" lIns="0" rIns="0" tIns="0" bIns="0">
+            <a:noAutofit/>
+          </a:bodyPr>
+          <a:lstStyle/>
+          <a:p>
+            <a:pPr algn="l"/>
+            <a:r>
+              <a:rPr sz="2400" b="0" i="0">
+                <a:solidFill>
+                  <a:srgbClr val="8FA3B8"/>
+                </a:solidFill>
+                <a:latin typeface="Roboto"/>
+              </a:rPr>
+              <a:t>new enterprises</a:t>
             </a:r>
           </a:p>
         </p:txBody>
@@ -3849,8 +4803,8 @@
   <p:clrMapOvr>
     <a:masterClrMapping/>
   </p:clrMapOvr>
-  <p:transition xmlns:p14="http://schemas.microsoft.com/office/powerpoint/2010/main" spd="fast" advClick="1" p14:dur="400">
-    <p:fade/>
+  <p:transition xmlns:p14="http://schemas.microsoft.com/office/powerpoint/2010/main" spd="med" advClick="1" p14:dur="600">
+    <p:zoom dir="in"/>
   </p:transition>
   <p:timing>
     <p:tnLst>
@@ -3916,7 +4870,7 @@
                   <p:par>
                     <p:cTn id="8" fill="hold">
                       <p:stCondLst>
-                        <p:cond delay="indefinite"/>
+                        <p:cond delay="0"/>
                       </p:stCondLst>
                       <p:childTnLst>
                         <p:par>
@@ -3926,7 +4880,7 @@
                             </p:stCondLst>
                             <p:childTnLst>
                               <p:par>
-                                <p:cTn id="10" presetID="22" presetClass="entr" presetSubtype="0" fill="hold" grpId="0" nodeType="clickEffect">
+                                <p:cTn id="10" presetID="8" presetClass="entr" presetSubtype="0" fill="hold" grpId="0" nodeType="afterEffect">
                                   <p:stCondLst>
                                     <p:cond delay="0"/>
                                   </p:stCondLst>
@@ -3949,9 +4903,44 @@
                                         <p:strVal val="visible"/>
                                       </p:to>
                                     </p:set>
-                                    <p:animEffect transition="in" filter="wipe(left)">
+                                    <p:animEffect transition="in" filter="box(in)">
                                       <p:cBhvr>
-                                        <p:cTn id="12" dur="400"/>
+                                        <p:cTn id="12" dur="500"/>
+                                        <p:tgtEl>
+                                          <p:spTgt spid="4"/>
+                                        </p:tgtEl>
+                                      </p:cBhvr>
+                                    </p:animEffect>
+                                  </p:childTnLst>
+                                </p:cTn>
+                              </p:par>
+                            </p:childTnLst>
+                          </p:cTn>
+                        </p:par>
+                      </p:childTnLst>
+                    </p:cTn>
+                  </p:par>
+                  <p:par>
+                    <p:cTn id="13" fill="hold">
+                      <p:stCondLst>
+                        <p:cond delay="0"/>
+                      </p:stCondLst>
+                      <p:childTnLst>
+                        <p:par>
+                          <p:cTn id="14" fill="hold">
+                            <p:stCondLst>
+                              <p:cond delay="0"/>
+                            </p:stCondLst>
+                            <p:childTnLst>
+                              <p:par>
+                                <p:cTn id="15" presetID="10" presetClass="exit" presetSubtype="0" fill="hold" grpId="0" nodeType="afterEffect">
+                                  <p:stCondLst>
+                                    <p:cond delay="1500"/>
+                                  </p:stCondLst>
+                                  <p:childTnLst>
+                                    <p:animEffect transition="out" filter="fade">
+                                      <p:cBhvr>
+                                        <p:cTn id="16" dur="500"/>
                                         <p:tgtEl>
                                           <p:spTgt spid="4"/>
                                         </p:tgtEl>
@@ -3959,7 +4948,52 @@
                                     </p:animEffect>
                                     <p:set>
                                       <p:cBhvr>
-                                        <p:cTn id="13" dur="1" fill="hold">
+                                        <p:cTn id="17" dur="1" fill="hold">
+                                          <p:stCondLst>
+                                            <p:cond delay="500"/>
+                                          </p:stCondLst>
+                                        </p:cTn>
+                                        <p:tgtEl>
+                                          <p:spTgt spid="4"/>
+                                        </p:tgtEl>
+                                        <p:attrNameLst>
+                                          <p:attrName>style.visibility</p:attrName>
+                                        </p:attrNameLst>
+                                      </p:cBhvr>
+                                      <p:to>
+                                        <p:strVal val="hidden"/>
+                                      </p:to>
+                                    </p:set>
+                                  </p:childTnLst>
+                                </p:cTn>
+                              </p:par>
+                            </p:childTnLst>
+                          </p:cTn>
+                        </p:par>
+                      </p:childTnLst>
+                    </p:cTn>
+                  </p:par>
+                  <p:par>
+                    <p:cTn id="18" fill="hold">
+                      <p:stCondLst>
+                        <p:cond delay="0"/>
+                      </p:stCondLst>
+                      <p:childTnLst>
+                        <p:par>
+                          <p:cTn id="19" fill="hold">
+                            <p:stCondLst>
+                              <p:cond delay="0"/>
+                            </p:stCondLst>
+                            <p:childTnLst>
+                              <p:par>
+                                <p:cTn id="20" presetID="21" presetClass="entr" presetSubtype="0" fill="hold" grpId="0" nodeType="afterEffect">
+                                  <p:stCondLst>
+                                    <p:cond delay="0"/>
+                                  </p:stCondLst>
+                                  <p:childTnLst>
+                                    <p:set>
+                                      <p:cBhvr>
+                                        <p:cTn id="21" dur="1" fill="hold">
                                           <p:stCondLst>
                                             <p:cond delay="0"/>
                                           </p:stCondLst>
@@ -3975,44 +5009,17 @@
                                         <p:strVal val="visible"/>
                                       </p:to>
                                     </p:set>
-                                    <p:animEffect transition="in" filter="wipe(left)">
+                                    <p:animEffect transition="in" filter="wheel(3)">
                                       <p:cBhvr>
-                                        <p:cTn id="14" dur="400"/>
+                                        <p:cTn id="22" dur="500"/>
                                         <p:tgtEl>
                                           <p:spTgt spid="5"/>
                                         </p:tgtEl>
                                       </p:cBhvr>
                                     </p:animEffect>
-                                  </p:childTnLst>
-                                </p:cTn>
-                              </p:par>
-                            </p:childTnLst>
-                          </p:cTn>
-                        </p:par>
-                      </p:childTnLst>
-                    </p:cTn>
-                  </p:par>
-                  <p:par>
-                    <p:cTn id="15" fill="hold">
-                      <p:stCondLst>
-                        <p:cond delay="indefinite"/>
-                      </p:stCondLst>
-                      <p:childTnLst>
-                        <p:par>
-                          <p:cTn id="16" fill="hold">
-                            <p:stCondLst>
-                              <p:cond delay="0"/>
-                            </p:stCondLst>
-                            <p:childTnLst>
-                              <p:par>
-                                <p:cTn id="17" presetID="22" presetClass="entr" presetSubtype="0" fill="hold" grpId="0" nodeType="clickEffect">
-                                  <p:stCondLst>
-                                    <p:cond delay="0"/>
-                                  </p:stCondLst>
-                                  <p:childTnLst>
                                     <p:set>
                                       <p:cBhvr>
-                                        <p:cTn id="18" dur="1" fill="hold">
+                                        <p:cTn id="23" dur="1" fill="hold">
                                           <p:stCondLst>
                                             <p:cond delay="0"/>
                                           </p:stCondLst>
@@ -4028,9 +5035,9 @@
                                         <p:strVal val="visible"/>
                                       </p:to>
                                     </p:set>
-                                    <p:animEffect transition="in" filter="wipe(left)">
+                                    <p:animEffect transition="in" filter="wheel(3)">
                                       <p:cBhvr>
-                                        <p:cTn id="19" dur="400"/>
+                                        <p:cTn id="24" dur="500"/>
                                         <p:tgtEl>
                                           <p:spTgt spid="6"/>
                                         </p:tgtEl>
@@ -4038,7 +5045,7 @@
                                     </p:animEffect>
                                     <p:set>
                                       <p:cBhvr>
-                                        <p:cTn id="20" dur="1" fill="hold">
+                                        <p:cTn id="25" dur="1" fill="hold">
                                           <p:stCondLst>
                                             <p:cond delay="0"/>
                                           </p:stCondLst>
@@ -4054,44 +5061,17 @@
                                         <p:strVal val="visible"/>
                                       </p:to>
                                     </p:set>
-                                    <p:animEffect transition="in" filter="wipe(left)">
+                                    <p:animEffect transition="in" filter="wheel(3)">
                                       <p:cBhvr>
-                                        <p:cTn id="21" dur="400"/>
+                                        <p:cTn id="26" dur="500"/>
                                         <p:tgtEl>
                                           <p:spTgt spid="7"/>
                                         </p:tgtEl>
                                       </p:cBhvr>
                                     </p:animEffect>
-                                  </p:childTnLst>
-                                </p:cTn>
-                              </p:par>
-                            </p:childTnLst>
-                          </p:cTn>
-                        </p:par>
-                      </p:childTnLst>
-                    </p:cTn>
-                  </p:par>
-                  <p:par>
-                    <p:cTn id="22" fill="hold">
-                      <p:stCondLst>
-                        <p:cond delay="indefinite"/>
-                      </p:stCondLst>
-                      <p:childTnLst>
-                        <p:par>
-                          <p:cTn id="23" fill="hold">
-                            <p:stCondLst>
-                              <p:cond delay="0"/>
-                            </p:stCondLst>
-                            <p:childTnLst>
-                              <p:par>
-                                <p:cTn id="24" presetID="22" presetClass="entr" presetSubtype="0" fill="hold" grpId="0" nodeType="clickEffect">
-                                  <p:stCondLst>
-                                    <p:cond delay="0"/>
-                                  </p:stCondLst>
-                                  <p:childTnLst>
                                     <p:set>
                                       <p:cBhvr>
-                                        <p:cTn id="25" dur="1" fill="hold">
+                                        <p:cTn id="27" dur="1" fill="hold">
                                           <p:stCondLst>
                                             <p:cond delay="0"/>
                                           </p:stCondLst>
@@ -4107,9 +5087,9 @@
                                         <p:strVal val="visible"/>
                                       </p:to>
                                     </p:set>
-                                    <p:animEffect transition="in" filter="wipe(left)">
+                                    <p:animEffect transition="in" filter="wheel(3)">
                                       <p:cBhvr>
-                                        <p:cTn id="26" dur="400"/>
+                                        <p:cTn id="28" dur="500"/>
                                         <p:tgtEl>
                                           <p:spTgt spid="8"/>
                                         </p:tgtEl>
@@ -4117,7 +5097,7 @@
                                     </p:animEffect>
                                     <p:set>
                                       <p:cBhvr>
-                                        <p:cTn id="27" dur="1" fill="hold">
+                                        <p:cTn id="29" dur="1" fill="hold">
                                           <p:stCondLst>
                                             <p:cond delay="0"/>
                                           </p:stCondLst>
@@ -4133,396 +5113,11 @@
                                         <p:strVal val="visible"/>
                                       </p:to>
                                     </p:set>
-                                    <p:animEffect transition="in" filter="wipe(left)">
+                                    <p:animEffect transition="in" filter="wheel(3)">
                                       <p:cBhvr>
-                                        <p:cTn id="28" dur="400"/>
+                                        <p:cTn id="30" dur="500"/>
                                         <p:tgtEl>
                                           <p:spTgt spid="9"/>
-                                        </p:tgtEl>
-                                      </p:cBhvr>
-                                    </p:animEffect>
-                                  </p:childTnLst>
-                                </p:cTn>
-                              </p:par>
-                            </p:childTnLst>
-                          </p:cTn>
-                        </p:par>
-                      </p:childTnLst>
-                    </p:cTn>
-                  </p:par>
-                  <p:par>
-                    <p:cTn id="29" fill="hold">
-                      <p:stCondLst>
-                        <p:cond delay="indefinite"/>
-                      </p:stCondLst>
-                      <p:childTnLst>
-                        <p:par>
-                          <p:cTn id="30" fill="hold">
-                            <p:stCondLst>
-                              <p:cond delay="0"/>
-                            </p:stCondLst>
-                            <p:childTnLst>
-                              <p:par>
-                                <p:cTn id="31" presetID="22" presetClass="entr" presetSubtype="0" fill="hold" grpId="0" nodeType="clickEffect">
-                                  <p:stCondLst>
-                                    <p:cond delay="0"/>
-                                  </p:stCondLst>
-                                  <p:childTnLst>
-                                    <p:set>
-                                      <p:cBhvr>
-                                        <p:cTn id="32" dur="1" fill="hold">
-                                          <p:stCondLst>
-                                            <p:cond delay="0"/>
-                                          </p:stCondLst>
-                                        </p:cTn>
-                                        <p:tgtEl>
-                                          <p:spTgt spid="10"/>
-                                        </p:tgtEl>
-                                        <p:attrNameLst>
-                                          <p:attrName>style.visibility</p:attrName>
-                                        </p:attrNameLst>
-                                      </p:cBhvr>
-                                      <p:to>
-                                        <p:strVal val="visible"/>
-                                      </p:to>
-                                    </p:set>
-                                    <p:animEffect transition="in" filter="wipe(left)">
-                                      <p:cBhvr>
-                                        <p:cTn id="33" dur="400"/>
-                                        <p:tgtEl>
-                                          <p:spTgt spid="10"/>
-                                        </p:tgtEl>
-                                      </p:cBhvr>
-                                    </p:animEffect>
-                                    <p:set>
-                                      <p:cBhvr>
-                                        <p:cTn id="34" dur="1" fill="hold">
-                                          <p:stCondLst>
-                                            <p:cond delay="0"/>
-                                          </p:stCondLst>
-                                        </p:cTn>
-                                        <p:tgtEl>
-                                          <p:spTgt spid="11"/>
-                                        </p:tgtEl>
-                                        <p:attrNameLst>
-                                          <p:attrName>style.visibility</p:attrName>
-                                        </p:attrNameLst>
-                                      </p:cBhvr>
-                                      <p:to>
-                                        <p:strVal val="visible"/>
-                                      </p:to>
-                                    </p:set>
-                                    <p:animEffect transition="in" filter="wipe(left)">
-                                      <p:cBhvr>
-                                        <p:cTn id="35" dur="400"/>
-                                        <p:tgtEl>
-                                          <p:spTgt spid="11"/>
-                                        </p:tgtEl>
-                                      </p:cBhvr>
-                                    </p:animEffect>
-                                  </p:childTnLst>
-                                </p:cTn>
-                              </p:par>
-                            </p:childTnLst>
-                          </p:cTn>
-                        </p:par>
-                      </p:childTnLst>
-                    </p:cTn>
-                  </p:par>
-                </p:childTnLst>
-              </p:cTn>
-              <p:prevCondLst>
-                <p:cond evt="onPrev" delay="0">
-                  <p:tgtEl>
-                    <p:sldTgt/>
-                  </p:tgtEl>
-                </p:cond>
-              </p:prevCondLst>
-              <p:nextCondLst>
-                <p:cond evt="onNext" delay="0">
-                  <p:tgtEl>
-                    <p:sldTgt/>
-                  </p:tgtEl>
-                </p:cond>
-              </p:nextCondLst>
-            </p:seq>
-          </p:childTnLst>
-        </p:cTn>
-      </p:par>
-    </p:tnLst>
-  </p:timing>
-</p:sld>
-</file>
-
-<file path=ppt/slides/slide3.xml><?xml version="1.0" encoding="utf-8"?>
-<p:sld xmlns:a="http://schemas.openxmlformats.org/drawingml/2006/main" xmlns:p="http://schemas.openxmlformats.org/presentationml/2006/main" xmlns:r="http://schemas.openxmlformats.org/officeDocument/2006/relationships">
-  <p:cSld>
-    <p:spTree>
-      <p:nvGrpSpPr>
-        <p:cNvPr id="1" name=""/>
-        <p:cNvGrpSpPr/>
-        <p:nvPr/>
-      </p:nvGrpSpPr>
-      <p:grpSpPr/>
-      <p:sp>
-        <p:nvSpPr>
-          <p:cNvPr id="2" name="Rectangle 1"/>
-          <p:cNvSpPr/>
-          <p:nvPr/>
-        </p:nvSpPr>
-        <p:spPr>
-          <a:xfrm>
-            <a:off x="0" y="0"/>
-            <a:ext cx="12192000" cy="6858000"/>
-          </a:xfrm>
-          <a:prstGeom prst="rect">
-            <a:avLst/>
-          </a:prstGeom>
-          <a:solidFill>
-            <a:srgbClr val="101A0B"/>
-          </a:solidFill>
-          <a:ln>
-            <a:noFill/>
-          </a:ln>
-          <a:effectLst/>
-        </p:spPr>
-        <p:style>
-          <a:lnRef idx="1">
-            <a:schemeClr val="accent1"/>
-          </a:lnRef>
-          <a:fillRef idx="3">
-            <a:schemeClr val="accent1"/>
-          </a:fillRef>
-          <a:effectRef idx="2">
-            <a:schemeClr val="accent1"/>
-          </a:effectRef>
-          <a:fontRef idx="minor">
-            <a:schemeClr val="lt1"/>
-          </a:fontRef>
-        </p:style>
-        <p:txBody>
-          <a:bodyPr rtlCol="0" anchor="ctr"/>
-          <a:lstStyle/>
-          <a:p>
-            <a:pPr algn="ctr"/>
-          </a:p>
-        </p:txBody>
-      </p:sp>
-      <p:sp>
-        <p:nvSpPr>
-          <p:cNvPr id="3" name="TextBox 2"/>
-          <p:cNvSpPr txBox="1"/>
-          <p:nvPr/>
-        </p:nvSpPr>
-        <p:spPr>
-          <a:xfrm>
-            <a:off x="3324225" y="2133600"/>
-            <a:ext cx="5543550" cy="1685925"/>
-          </a:xfrm>
-          <a:prstGeom prst="rect">
-            <a:avLst/>
-          </a:prstGeom>
-          <a:noFill/>
-        </p:spPr>
-        <p:txBody>
-          <a:bodyPr wrap="none" anchor="t" lIns="0" rIns="0" tIns="0" bIns="0">
-            <a:noAutofit/>
-          </a:bodyPr>
-          <a:lstStyle/>
-          <a:p>
-            <a:pPr algn="ctr"/>
-            <a:r>
-              <a:rPr sz="18000" b="1" i="0">
-                <a:solidFill>
-                  <a:srgbClr val="B8FF00"/>
-                </a:solidFill>
-                <a:latin typeface="Roboto"/>
-              </a:rPr>
-              <a:t>+38%</a:t>
-            </a:r>
-          </a:p>
-        </p:txBody>
-      </p:sp>
-      <p:sp>
-        <p:nvSpPr>
-          <p:cNvPr id="4" name="TextBox 3"/>
-          <p:cNvSpPr txBox="1"/>
-          <p:nvPr/>
-        </p:nvSpPr>
-        <p:spPr>
-          <a:xfrm>
-            <a:off x="3552825" y="4638675"/>
-            <a:ext cx="5095875" cy="390525"/>
-          </a:xfrm>
-          <a:prstGeom prst="rect">
-            <a:avLst/>
-          </a:prstGeom>
-          <a:noFill/>
-        </p:spPr>
-        <p:txBody>
-          <a:bodyPr wrap="none" anchor="t" lIns="0" rIns="0" tIns="0" bIns="0">
-            <a:noAutofit/>
-          </a:bodyPr>
-          <a:lstStyle/>
-          <a:p>
-            <a:pPr algn="ctr"/>
-            <a:r>
-              <a:rPr sz="3300" b="0" i="0">
-                <a:solidFill>
-                  <a:srgbClr val="D7E8C4"/>
-                </a:solidFill>
-                <a:latin typeface="Roboto"/>
-              </a:rPr>
-              <a:t>year-over-year active teams</a:t>
-            </a:r>
-          </a:p>
-        </p:txBody>
-      </p:sp>
-    </p:spTree>
-  </p:cSld>
-  <p:clrMapOvr>
-    <a:masterClrMapping/>
-  </p:clrMapOvr>
-  <p:transition xmlns:p14="http://schemas.microsoft.com/office/powerpoint/2010/main" spd="med" advClick="1" p14:dur="600">
-    <p:zoom dir="in"/>
-  </p:transition>
-  <p:timing>
-    <p:tnLst>
-      <p:par>
-        <p:cTn id="1" dur="indefinite" restart="never" nodeType="tmRoot">
-          <p:childTnLst>
-            <p:seq concurrent="1" nextAc="seek">
-              <p:cTn id="2" dur="indefinite" nodeType="mainSeq">
-                <p:childTnLst>
-                  <p:par>
-                    <p:cTn id="3" fill="hold">
-                      <p:stCondLst>
-                        <p:cond delay="indefinite"/>
-                      </p:stCondLst>
-                      <p:childTnLst>
-                        <p:par>
-                          <p:cTn id="4" fill="hold">
-                            <p:stCondLst>
-                              <p:cond delay="0"/>
-                            </p:stCondLst>
-                            <p:childTnLst>
-                              <p:par>
-                                <p:cTn id="5" presetID="8" presetClass="entr" presetSubtype="0" fill="hold" grpId="0" nodeType="clickEffect">
-                                  <p:stCondLst>
-                                    <p:cond delay="0"/>
-                                  </p:stCondLst>
-                                  <p:childTnLst>
-                                    <p:set>
-                                      <p:cBhvr>
-                                        <p:cTn id="6" dur="1" fill="hold">
-                                          <p:stCondLst>
-                                            <p:cond delay="0"/>
-                                          </p:stCondLst>
-                                        </p:cTn>
-                                        <p:tgtEl>
-                                          <p:spTgt spid="3"/>
-                                        </p:tgtEl>
-                                        <p:attrNameLst>
-                                          <p:attrName>style.visibility</p:attrName>
-                                        </p:attrNameLst>
-                                      </p:cBhvr>
-                                      <p:to>
-                                        <p:strVal val="visible"/>
-                                      </p:to>
-                                    </p:set>
-                                    <p:animEffect transition="in" filter="box(in)">
-                                      <p:cBhvr>
-                                        <p:cTn id="7" dur="500"/>
-                                        <p:tgtEl>
-                                          <p:spTgt spid="3"/>
-                                        </p:tgtEl>
-                                      </p:cBhvr>
-                                    </p:animEffect>
-                                  </p:childTnLst>
-                                </p:cTn>
-                              </p:par>
-                            </p:childTnLst>
-                          </p:cTn>
-                        </p:par>
-                      </p:childTnLst>
-                    </p:cTn>
-                  </p:par>
-                  <p:par>
-                    <p:cTn id="8" fill="hold">
-                      <p:stCondLst>
-                        <p:cond delay="0"/>
-                      </p:stCondLst>
-                      <p:childTnLst>
-                        <p:par>
-                          <p:cTn id="9" fill="hold">
-                            <p:stCondLst>
-                              <p:cond delay="0"/>
-                            </p:stCondLst>
-                            <p:childTnLst>
-                              <p:par>
-                                <p:cTn id="10" presetID="10" presetClass="exit" presetSubtype="0" fill="hold" grpId="0" nodeType="afterEffect">
-                                  <p:stCondLst>
-                                    <p:cond delay="1000"/>
-                                  </p:stCondLst>
-                                  <p:childTnLst>
-                                    <p:animEffect transition="out" filter="fade">
-                                      <p:cBhvr>
-                                        <p:cTn id="11" dur="500"/>
-                                        <p:tgtEl>
-                                          <p:spTgt spid="3"/>
-                                        </p:tgtEl>
-                                      </p:cBhvr>
-                                    </p:animEffect>
-                                    <p:set>
-                                      <p:cBhvr>
-                                        <p:cTn id="12" dur="1" fill="hold">
-                                          <p:stCondLst>
-                                            <p:cond delay="500"/>
-                                          </p:stCondLst>
-                                        </p:cTn>
-                                        <p:tgtEl>
-                                          <p:spTgt spid="3"/>
-                                        </p:tgtEl>
-                                        <p:attrNameLst>
-                                          <p:attrName>style.visibility</p:attrName>
-                                        </p:attrNameLst>
-                                      </p:cBhvr>
-                                      <p:to>
-                                        <p:strVal val="hidden"/>
-                                      </p:to>
-                                    </p:set>
-                                  </p:childTnLst>
-                                </p:cTn>
-                              </p:par>
-                              <p:par>
-                                <p:cTn id="13" presetID="10" presetClass="entr" presetSubtype="0" fill="hold" grpId="0" nodeType="withEffect">
-                                  <p:stCondLst>
-                                    <p:cond delay="0"/>
-                                  </p:stCondLst>
-                                  <p:childTnLst>
-                                    <p:set>
-                                      <p:cBhvr>
-                                        <p:cTn id="14" dur="1" fill="hold">
-                                          <p:stCondLst>
-                                            <p:cond delay="0"/>
-                                          </p:stCondLst>
-                                        </p:cTn>
-                                        <p:tgtEl>
-                                          <p:spTgt spid="4"/>
-                                        </p:tgtEl>
-                                        <p:attrNameLst>
-                                          <p:attrName>style.visibility</p:attrName>
-                                        </p:attrNameLst>
-                                      </p:cBhvr>
-                                      <p:to>
-                                        <p:strVal val="visible"/>
-                                      </p:to>
-                                    </p:set>
-                                    <p:animEffect transition="in" filter="fade">
-                                      <p:cBhvr>
-                                        <p:cTn id="15" dur="500"/>
-                                        <p:tgtEl>
-                                          <p:spTgt spid="4"/>
                                         </p:tgtEl>
                                       </p:cBhvr>
                                     </p:animEffect>
@@ -4584,8 +5179,62 @@
           <a:prstGeom prst="rect">
             <a:avLst/>
           </a:prstGeom>
+          <a:gradFill rotWithShape="1">
+            <a:gsLst>
+              <a:gs pos="0">
+                <a:srgbClr val="0A1626"/>
+              </a:gs>
+              <a:gs pos="100000">
+                <a:srgbClr val="122849"/>
+              </a:gs>
+            </a:gsLst>
+            <a:lin ang="8100000" scaled="0"/>
+          </a:gradFill>
+          <a:ln>
+            <a:noFill/>
+          </a:ln>
+          <a:effectLst/>
+        </p:spPr>
+        <p:style>
+          <a:lnRef idx="1">
+            <a:schemeClr val="accent1"/>
+          </a:lnRef>
+          <a:fillRef idx="3">
+            <a:schemeClr val="accent1"/>
+          </a:fillRef>
+          <a:effectRef idx="2">
+            <a:schemeClr val="accent1"/>
+          </a:effectRef>
+          <a:fontRef idx="minor">
+            <a:schemeClr val="lt1"/>
+          </a:fontRef>
+        </p:style>
+        <p:txBody>
+          <a:bodyPr rtlCol="0" anchor="ctr"/>
+          <a:lstStyle/>
+          <a:p>
+            <a:pPr algn="ctr"/>
+          </a:p>
+        </p:txBody>
+      </p:sp>
+      <p:sp>
+        <p:nvSpPr>
+          <p:cNvPr id="3" name="Oval 2"/>
+          <p:cNvSpPr/>
+          <p:nvPr/>
+        </p:nvSpPr>
+        <p:spPr>
+          <a:xfrm>
+            <a:off x="-1019175" y="3552825"/>
+            <a:ext cx="4953000" cy="4953000"/>
+          </a:xfrm>
+          <a:prstGeom prst="ellipse">
+            <a:avLst/>
+          </a:prstGeom>
           <a:solidFill>
-            <a:srgbClr val="0B1B2B"/>
+            <a:srgbClr val="163358">
+              <a:alpha val="34901"/>
+            </a:srgbClr>
           </a:solidFill>
           <a:ln>
             <a:noFill/>
@@ -4616,14 +5265,60 @@
       </p:sp>
       <p:sp>
         <p:nvSpPr>
-          <p:cNvPr id="3" name="TextBox 2"/>
+          <p:cNvPr id="4" name="Rounded Rectangle 3"/>
+          <p:cNvSpPr/>
+          <p:nvPr/>
+        </p:nvSpPr>
+        <p:spPr>
+          <a:xfrm>
+            <a:off x="5753100" y="2562225"/>
+            <a:ext cx="685800" cy="76200"/>
+          </a:xfrm>
+          <a:prstGeom prst="roundRect">
+            <a:avLst>
+              <a:gd name="adj" fmla="val 50000"/>
+            </a:avLst>
+          </a:prstGeom>
+          <a:solidFill>
+            <a:srgbClr val="B8FF00"/>
+          </a:solidFill>
+          <a:ln>
+            <a:noFill/>
+          </a:ln>
+          <a:effectLst/>
+        </p:spPr>
+        <p:style>
+          <a:lnRef idx="1">
+            <a:schemeClr val="accent1"/>
+          </a:lnRef>
+          <a:fillRef idx="3">
+            <a:schemeClr val="accent1"/>
+          </a:fillRef>
+          <a:effectRef idx="2">
+            <a:schemeClr val="accent1"/>
+          </a:effectRef>
+          <a:fontRef idx="minor">
+            <a:schemeClr val="lt1"/>
+          </a:fontRef>
+        </p:style>
+        <p:txBody>
+          <a:bodyPr rtlCol="0" anchor="ctr"/>
+          <a:lstStyle/>
+          <a:p>
+            <a:pPr algn="ctr"/>
+          </a:p>
+        </p:txBody>
+      </p:sp>
+      <p:sp>
+        <p:nvSpPr>
+          <p:cNvPr id="5" name="TextBox 4"/>
           <p:cNvSpPr txBox="1"/>
           <p:nvPr/>
         </p:nvSpPr>
         <p:spPr>
           <a:xfrm>
-            <a:off x="3257550" y="2647950"/>
-            <a:ext cx="5676900" cy="962025"/>
+            <a:off x="2933700" y="2962275"/>
+            <a:ext cx="6334125" cy="876300"/>
           </a:xfrm>
           <a:prstGeom prst="rect">
             <a:avLst/>
@@ -4639,26 +5334,41 @@
             <a:pPr algn="ctr"/>
             <a:r>
               <a:rPr sz="9000" b="1" i="0">
-                <a:solidFill>
-                  <a:srgbClr val="FFFFFF"/>
-                </a:solidFill>
+                <a:gradFill rotWithShape="1">
+                  <a:gsLst>
+                    <a:gs pos="0">
+                      <a:srgbClr val="B7FE02"/>
+                    </a:gs>
+                    <a:gs pos="100000">
+                      <a:srgbClr val="7DD3F9"/>
+                    </a:gs>
+                  </a:gsLst>
+                  <a:lin ang="1200000" scaled="0"/>
+                </a:gradFill>
+                <a:effectLst>
+                  <a:outerShdw blurRad="419100" dist="95250" dir="5400000" rotWithShape="0">
+                    <a:srgbClr val="000000">
+                      <a:alpha val="40000"/>
+                    </a:srgbClr>
+                  </a:outerShdw>
+                </a:effectLst>
                 <a:latin typeface="Roboto"/>
               </a:rPr>
-              <a:t>Questions?</a:t>
-            </a:r>
-          </a:p>
-        </p:txBody>
-      </p:sp>
-      <p:sp>
-        <p:nvSpPr>
-          <p:cNvPr id="4" name="TextBox 3"/>
+              <a:t>Let's build it.</a:t>
+            </a:r>
+          </a:p>
+        </p:txBody>
+      </p:sp>
+      <p:sp>
+        <p:nvSpPr>
+          <p:cNvPr id="6" name="TextBox 5"/>
           <p:cNvSpPr txBox="1"/>
           <p:nvPr/>
         </p:nvSpPr>
         <p:spPr>
           <a:xfrm>
-            <a:off x="4419600" y="4095750"/>
-            <a:ext cx="3352800" cy="361950"/>
+            <a:off x="2952750" y="4391025"/>
+            <a:ext cx="6296025" cy="304800"/>
           </a:xfrm>
           <a:prstGeom prst="rect">
             <a:avLst/>
@@ -4673,13 +5383,13 @@
           <a:p>
             <a:pPr algn="ctr"/>
             <a:r>
-              <a:rPr sz="3000" b="0" i="0">
+              <a:rPr sz="2700" b="0" i="0">
                 <a:solidFill>
-                  <a:srgbClr val="8CE1FF"/>
+                  <a:srgbClr val="8FA3B8"/>
                 </a:solidFill>
                 <a:latin typeface="Roboto"/>
               </a:rPr>
-              <a:t>thanks for watching</a:t>
+              <a:t>Questions, ideas, and bold bets welcome.</a:t>
             </a:r>
           </a:p>
         </p:txBody>

</xml_diff>

<commit_message>
Lead slide animations with the main element
Reorder the example's entrance animations so each slide reveals its main element
first (the headline, the hero number) and then its supporting detail, instead of
animating the eyebrow/caption ahead of it. The hero metric no longer fades itself
out before its caption and stats appear.

Co-Authored-By: Claude Opus 4.8 <noreply@anthropic.com>
Claude-Session: https://claude.ai/code/session_01TpdN8ZGDXbofsc2mQRueCa
</commit_message>
<xml_diff>
--- a/examples/slide_effects_deck.pptx
+++ b/examples/slide_effects_deck.pptx
@@ -3243,41 +3243,6 @@
         </p:nvSpPr>
         <p:spPr>
           <a:xfrm>
-            <a:off x="971550" y="2400300"/>
-            <a:ext cx="5162550" cy="219075"/>
-          </a:xfrm>
-          <a:prstGeom prst="rect">
-            <a:avLst/>
-          </a:prstGeom>
-          <a:noFill/>
-        </p:spPr>
-        <p:txBody>
-          <a:bodyPr wrap="none" anchor="t" lIns="0" rIns="0" tIns="0" bIns="0">
-            <a:noAutofit/>
-          </a:bodyPr>
-          <a:lstStyle/>
-          <a:p>
-            <a:pPr algn="l"/>
-            <a:r>
-              <a:rPr sz="2100" b="1" i="0">
-                <a:solidFill>
-                  <a:srgbClr val="7DD3FC"/>
-                </a:solidFill>
-                <a:latin typeface="Roboto"/>
-              </a:rPr>
-              <a:t>QUARTERLY BUSINESS REVIEW</a:t>
-            </a:r>
-          </a:p>
-        </p:txBody>
-      </p:sp>
-      <p:sp>
-        <p:nvSpPr>
-          <p:cNvPr id="6" name="TextBox 5"/>
-          <p:cNvSpPr txBox="1"/>
-          <p:nvPr/>
-        </p:nvSpPr>
-        <p:spPr>
-          <a:xfrm>
             <a:off x="971550" y="3086100"/>
             <a:ext cx="7086600" cy="1924050"/>
           </a:xfrm>
@@ -3351,6 +3316,41 @@
                 <a:latin typeface="Roboto"/>
               </a:rPr>
               <a:t>actually matters</a:t>
+            </a:r>
+          </a:p>
+        </p:txBody>
+      </p:sp>
+      <p:sp>
+        <p:nvSpPr>
+          <p:cNvPr id="6" name="TextBox 5"/>
+          <p:cNvSpPr txBox="1"/>
+          <p:nvPr/>
+        </p:nvSpPr>
+        <p:spPr>
+          <a:xfrm>
+            <a:off x="971550" y="2400300"/>
+            <a:ext cx="5162550" cy="219075"/>
+          </a:xfrm>
+          <a:prstGeom prst="rect">
+            <a:avLst/>
+          </a:prstGeom>
+          <a:noFill/>
+        </p:spPr>
+        <p:txBody>
+          <a:bodyPr wrap="none" anchor="t" lIns="0" rIns="0" tIns="0" bIns="0">
+            <a:noAutofit/>
+          </a:bodyPr>
+          <a:lstStyle/>
+          <a:p>
+            <a:pPr algn="l"/>
+            <a:r>
+              <a:rPr sz="2100" b="1" i="0">
+                <a:solidFill>
+                  <a:srgbClr val="7DD3FC"/>
+                </a:solidFill>
+                <a:latin typeface="Roboto"/>
+              </a:rPr>
+              <a:t>QUARTERLY BUSINESS REVIEW</a:t>
             </a:r>
           </a:p>
         </p:txBody>
@@ -3419,7 +3419,7 @@
                             </p:stCondLst>
                             <p:childTnLst>
                               <p:par>
-                                <p:cTn id="5" presetID="22" presetClass="entr" presetSubtype="0" fill="hold" grpId="0" nodeType="clickEffect">
+                                <p:cTn id="5" presetID="10" presetClass="entr" presetSubtype="0" fill="hold" grpId="0" nodeType="clickEffect">
                                   <p:stCondLst>
                                     <p:cond delay="0"/>
                                   </p:stCondLst>
@@ -3432,7 +3432,7 @@
                                           </p:stCondLst>
                                         </p:cTn>
                                         <p:tgtEl>
-                                          <p:spTgt spid="4"/>
+                                          <p:spTgt spid="5"/>
                                         </p:tgtEl>
                                         <p:attrNameLst>
                                           <p:attrName>style.visibility</p:attrName>
@@ -3442,11 +3442,11 @@
                                         <p:strVal val="visible"/>
                                       </p:to>
                                     </p:set>
-                                    <p:animEffect transition="in" filter="wipe(left)">
+                                    <p:animEffect transition="in" filter="fade">
                                       <p:cBhvr>
-                                        <p:cTn id="7" dur="400"/>
+                                        <p:cTn id="7" dur="600"/>
                                         <p:tgtEl>
-                                          <p:spTgt spid="4"/>
+                                          <p:spTgt spid="5"/>
                                         </p:tgtEl>
                                       </p:cBhvr>
                                     </p:animEffect>
@@ -3485,7 +3485,7 @@
                                           </p:stCondLst>
                                         </p:cTn>
                                         <p:tgtEl>
-                                          <p:spTgt spid="5"/>
+                                          <p:spTgt spid="6"/>
                                         </p:tgtEl>
                                         <p:attrNameLst>
                                           <p:attrName>style.visibility</p:attrName>
@@ -3499,7 +3499,7 @@
                                       <p:cBhvr>
                                         <p:cTn id="12" dur="500"/>
                                         <p:tgtEl>
-                                          <p:spTgt spid="5"/>
+                                          <p:spTgt spid="6"/>
                                         </p:tgtEl>
                                       </p:cBhvr>
                                     </p:animEffect>
@@ -3538,59 +3538,6 @@
                                           </p:stCondLst>
                                         </p:cTn>
                                         <p:tgtEl>
-                                          <p:spTgt spid="6"/>
-                                        </p:tgtEl>
-                                        <p:attrNameLst>
-                                          <p:attrName>style.visibility</p:attrName>
-                                        </p:attrNameLst>
-                                      </p:cBhvr>
-                                      <p:to>
-                                        <p:strVal val="visible"/>
-                                      </p:to>
-                                    </p:set>
-                                    <p:animEffect transition="in" filter="fade">
-                                      <p:cBhvr>
-                                        <p:cTn id="17" dur="600"/>
-                                        <p:tgtEl>
-                                          <p:spTgt spid="6"/>
-                                        </p:tgtEl>
-                                      </p:cBhvr>
-                                    </p:animEffect>
-                                  </p:childTnLst>
-                                </p:cTn>
-                              </p:par>
-                            </p:childTnLst>
-                          </p:cTn>
-                        </p:par>
-                      </p:childTnLst>
-                    </p:cTn>
-                  </p:par>
-                  <p:par>
-                    <p:cTn id="18" fill="hold">
-                      <p:stCondLst>
-                        <p:cond delay="0"/>
-                      </p:stCondLst>
-                      <p:childTnLst>
-                        <p:par>
-                          <p:cTn id="19" fill="hold">
-                            <p:stCondLst>
-                              <p:cond delay="0"/>
-                            </p:stCondLst>
-                            <p:childTnLst>
-                              <p:par>
-                                <p:cTn id="20" presetID="10" presetClass="entr" presetSubtype="0" fill="hold" grpId="0" nodeType="afterEffect">
-                                  <p:stCondLst>
-                                    <p:cond delay="0"/>
-                                  </p:stCondLst>
-                                  <p:childTnLst>
-                                    <p:set>
-                                      <p:cBhvr>
-                                        <p:cTn id="21" dur="1" fill="hold">
-                                          <p:stCondLst>
-                                            <p:cond delay="0"/>
-                                          </p:stCondLst>
-                                        </p:cTn>
-                                        <p:tgtEl>
                                           <p:spTgt spid="7"/>
                                         </p:tgtEl>
                                         <p:attrNameLst>
@@ -3603,7 +3550,7 @@
                                     </p:set>
                                     <p:animEffect transition="in" filter="fade">
                                       <p:cBhvr>
-                                        <p:cTn id="22" dur="500"/>
+                                        <p:cTn id="17" dur="500"/>
                                         <p:tgtEl>
                                           <p:spTgt spid="7"/>
                                         </p:tgtEl>
@@ -4546,41 +4493,6 @@
         </p:nvSpPr>
         <p:spPr>
           <a:xfrm>
-            <a:off x="3819525" y="1371600"/>
-            <a:ext cx="4562475" cy="276225"/>
-          </a:xfrm>
-          <a:prstGeom prst="rect">
-            <a:avLst/>
-          </a:prstGeom>
-          <a:noFill/>
-        </p:spPr>
-        <p:txBody>
-          <a:bodyPr wrap="none" anchor="t" lIns="0" rIns="0" tIns="0" bIns="0">
-            <a:noAutofit/>
-          </a:bodyPr>
-          <a:lstStyle/>
-          <a:p>
-            <a:pPr algn="ctr"/>
-            <a:r>
-              <a:rPr sz="2250" b="1" i="0">
-                <a:solidFill>
-                  <a:srgbClr val="7DD3FC"/>
-                </a:solidFill>
-                <a:latin typeface="Roboto"/>
-              </a:rPr>
-              <a:t>Active teams, year over year</a:t>
-            </a:r>
-          </a:p>
-        </p:txBody>
-      </p:sp>
-      <p:sp>
-        <p:nvSpPr>
-          <p:cNvPr id="4" name="TextBox 3"/>
-          <p:cNvSpPr txBox="1"/>
-          <p:nvPr/>
-        </p:nvSpPr>
-        <p:spPr>
-          <a:xfrm>
             <a:off x="2628900" y="2352675"/>
             <a:ext cx="6924675" cy="2085975"/>
           </a:xfrm>
@@ -4619,6 +4531,41 @@
                 <a:latin typeface="Roboto"/>
               </a:rPr>
               <a:t>+38%</a:t>
+            </a:r>
+          </a:p>
+        </p:txBody>
+      </p:sp>
+      <p:sp>
+        <p:nvSpPr>
+          <p:cNvPr id="4" name="TextBox 3"/>
+          <p:cNvSpPr txBox="1"/>
+          <p:nvPr/>
+        </p:nvSpPr>
+        <p:spPr>
+          <a:xfrm>
+            <a:off x="3819525" y="1371600"/>
+            <a:ext cx="4562475" cy="276225"/>
+          </a:xfrm>
+          <a:prstGeom prst="rect">
+            <a:avLst/>
+          </a:prstGeom>
+          <a:noFill/>
+        </p:spPr>
+        <p:txBody>
+          <a:bodyPr wrap="none" anchor="t" lIns="0" rIns="0" tIns="0" bIns="0">
+            <a:noAutofit/>
+          </a:bodyPr>
+          <a:lstStyle/>
+          <a:p>
+            <a:pPr algn="ctr"/>
+            <a:r>
+              <a:rPr sz="2250" b="1" i="0">
+                <a:solidFill>
+                  <a:srgbClr val="7DD3FC"/>
+                </a:solidFill>
+                <a:latin typeface="Roboto"/>
+              </a:rPr>
+              <a:t>Active teams, year over year</a:t>
             </a:r>
           </a:p>
         </p:txBody>
@@ -4827,7 +4774,7 @@
                             </p:stCondLst>
                             <p:childTnLst>
                               <p:par>
-                                <p:cTn id="5" presetID="10" presetClass="entr" presetSubtype="0" fill="hold" grpId="0" nodeType="clickEffect">
+                                <p:cTn id="5" presetID="8" presetClass="entr" presetSubtype="0" fill="hold" grpId="0" nodeType="clickEffect">
                                   <p:stCondLst>
                                     <p:cond delay="0"/>
                                   </p:stCondLst>
@@ -4850,7 +4797,7 @@
                                         <p:strVal val="visible"/>
                                       </p:to>
                                     </p:set>
-                                    <p:animEffect transition="in" filter="fade">
+                                    <p:animEffect transition="in" filter="box(in)">
                                       <p:cBhvr>
                                         <p:cTn id="7" dur="500"/>
                                         <p:tgtEl>
@@ -4880,7 +4827,7 @@
                             </p:stCondLst>
                             <p:childTnLst>
                               <p:par>
-                                <p:cTn id="10" presetID="8" presetClass="entr" presetSubtype="0" fill="hold" grpId="0" nodeType="afterEffect">
+                                <p:cTn id="10" presetID="10" presetClass="entr" presetSubtype="0" fill="hold" grpId="0" nodeType="afterEffect">
                                   <p:stCondLst>
                                     <p:cond delay="0"/>
                                   </p:stCondLst>
@@ -4903,7 +4850,7 @@
                                         <p:strVal val="visible"/>
                                       </p:to>
                                     </p:set>
-                                    <p:animEffect transition="in" filter="box(in)">
+                                    <p:animEffect transition="in" filter="fade">
                                       <p:cBhvr>
                                         <p:cTn id="12" dur="500"/>
                                         <p:tgtEl>
@@ -4933,67 +4880,14 @@
                             </p:stCondLst>
                             <p:childTnLst>
                               <p:par>
-                                <p:cTn id="15" presetID="10" presetClass="exit" presetSubtype="0" fill="hold" grpId="0" nodeType="afterEffect">
-                                  <p:stCondLst>
-                                    <p:cond delay="1500"/>
-                                  </p:stCondLst>
-                                  <p:childTnLst>
-                                    <p:animEffect transition="out" filter="fade">
-                                      <p:cBhvr>
-                                        <p:cTn id="16" dur="500"/>
-                                        <p:tgtEl>
-                                          <p:spTgt spid="4"/>
-                                        </p:tgtEl>
-                                      </p:cBhvr>
-                                    </p:animEffect>
-                                    <p:set>
-                                      <p:cBhvr>
-                                        <p:cTn id="17" dur="1" fill="hold">
-                                          <p:stCondLst>
-                                            <p:cond delay="500"/>
-                                          </p:stCondLst>
-                                        </p:cTn>
-                                        <p:tgtEl>
-                                          <p:spTgt spid="4"/>
-                                        </p:tgtEl>
-                                        <p:attrNameLst>
-                                          <p:attrName>style.visibility</p:attrName>
-                                        </p:attrNameLst>
-                                      </p:cBhvr>
-                                      <p:to>
-                                        <p:strVal val="hidden"/>
-                                      </p:to>
-                                    </p:set>
-                                  </p:childTnLst>
-                                </p:cTn>
-                              </p:par>
-                            </p:childTnLst>
-                          </p:cTn>
-                        </p:par>
-                      </p:childTnLst>
-                    </p:cTn>
-                  </p:par>
-                  <p:par>
-                    <p:cTn id="18" fill="hold">
-                      <p:stCondLst>
-                        <p:cond delay="0"/>
-                      </p:stCondLst>
-                      <p:childTnLst>
-                        <p:par>
-                          <p:cTn id="19" fill="hold">
-                            <p:stCondLst>
-                              <p:cond delay="0"/>
-                            </p:stCondLst>
-                            <p:childTnLst>
-                              <p:par>
-                                <p:cTn id="20" presetID="21" presetClass="entr" presetSubtype="0" fill="hold" grpId="0" nodeType="afterEffect">
+                                <p:cTn id="15" presetID="21" presetClass="entr" presetSubtype="0" fill="hold" grpId="0" nodeType="afterEffect">
                                   <p:stCondLst>
                                     <p:cond delay="0"/>
                                   </p:stCondLst>
                                   <p:childTnLst>
                                     <p:set>
                                       <p:cBhvr>
-                                        <p:cTn id="21" dur="1" fill="hold">
+                                        <p:cTn id="16" dur="1" fill="hold">
                                           <p:stCondLst>
                                             <p:cond delay="0"/>
                                           </p:stCondLst>
@@ -5011,7 +4905,7 @@
                                     </p:set>
                                     <p:animEffect transition="in" filter="wheel(3)">
                                       <p:cBhvr>
-                                        <p:cTn id="22" dur="500"/>
+                                        <p:cTn id="17" dur="500"/>
                                         <p:tgtEl>
                                           <p:spTgt spid="5"/>
                                         </p:tgtEl>
@@ -5019,7 +4913,7 @@
                                     </p:animEffect>
                                     <p:set>
                                       <p:cBhvr>
-                                        <p:cTn id="23" dur="1" fill="hold">
+                                        <p:cTn id="18" dur="1" fill="hold">
                                           <p:stCondLst>
                                             <p:cond delay="0"/>
                                           </p:stCondLst>
@@ -5037,7 +4931,7 @@
                                     </p:set>
                                     <p:animEffect transition="in" filter="wheel(3)">
                                       <p:cBhvr>
-                                        <p:cTn id="24" dur="500"/>
+                                        <p:cTn id="19" dur="500"/>
                                         <p:tgtEl>
                                           <p:spTgt spid="6"/>
                                         </p:tgtEl>
@@ -5045,7 +4939,7 @@
                                     </p:animEffect>
                                     <p:set>
                                       <p:cBhvr>
-                                        <p:cTn id="25" dur="1" fill="hold">
+                                        <p:cTn id="20" dur="1" fill="hold">
                                           <p:stCondLst>
                                             <p:cond delay="0"/>
                                           </p:stCondLst>
@@ -5063,7 +4957,7 @@
                                     </p:set>
                                     <p:animEffect transition="in" filter="wheel(3)">
                                       <p:cBhvr>
-                                        <p:cTn id="26" dur="500"/>
+                                        <p:cTn id="21" dur="500"/>
                                         <p:tgtEl>
                                           <p:spTgt spid="7"/>
                                         </p:tgtEl>
@@ -5071,7 +4965,7 @@
                                     </p:animEffect>
                                     <p:set>
                                       <p:cBhvr>
-                                        <p:cTn id="27" dur="1" fill="hold">
+                                        <p:cTn id="22" dur="1" fill="hold">
                                           <p:stCondLst>
                                             <p:cond delay="0"/>
                                           </p:stCondLst>
@@ -5089,7 +4983,7 @@
                                     </p:set>
                                     <p:animEffect transition="in" filter="wheel(3)">
                                       <p:cBhvr>
-                                        <p:cTn id="28" dur="500"/>
+                                        <p:cTn id="23" dur="500"/>
                                         <p:tgtEl>
                                           <p:spTgt spid="8"/>
                                         </p:tgtEl>
@@ -5097,7 +4991,7 @@
                                     </p:animEffect>
                                     <p:set>
                                       <p:cBhvr>
-                                        <p:cTn id="29" dur="1" fill="hold">
+                                        <p:cTn id="24" dur="1" fill="hold">
                                           <p:stCondLst>
                                             <p:cond delay="0"/>
                                           </p:stCondLst>
@@ -5115,7 +5009,7 @@
                                     </p:set>
                                     <p:animEffect transition="in" filter="wheel(3)">
                                       <p:cBhvr>
-                                        <p:cTn id="30" dur="500"/>
+                                        <p:cTn id="25" dur="500"/>
                                         <p:tgtEl>
                                           <p:spTgt spid="9"/>
                                         </p:tgtEl>

</xml_diff>